<commit_message>
Stage-1 deck: methodology slide now covers the detection system, not the comparison
Co-Authored-By: Claude Opus 5.5 <noreply@anthropic.com>
</commit_message>
<xml_diff>
--- a/reports/Stage1_Model_Selection_Slides.pptx
+++ b/reports/Stage1_Model_Selection_Slides.pptx
@@ -118,13 +118,13 @@
   <p:extLst>
     <p:ext uri="{521415D9-36F7-43E2-AB2F-B90AF26B5E84}">
       <p14:sectionLst xmlns:p14="http://schemas.microsoft.com/office/powerpoint/2010/main">
-        <p14:section name="Introduction" id="{eb988f47-f94b-ffa0-55e6-8cfde4a07103}">
+        <p14:section name="Introduction" id="{2c0c908e-17a2-ab44-7853-c5474073c9b0}">
           <p14:sldIdLst>
             <p14:sldId id="256"/>
             <p14:sldId id="257"/>
           </p14:sldIdLst>
         </p14:section>
-        <p14:section name="Models" id="{7c519ccc-c671-c067-ffab-3725fb319941}">
+        <p14:section name="Models" id="{cb0d21e4-4ed9-c85a-7795-fca6f7d3ce2b}">
           <p14:sldIdLst>
             <p14:sldId id="258"/>
             <p14:sldId id="259"/>
@@ -134,13 +134,13 @@
             <p14:sldId id="263"/>
           </p14:sldIdLst>
         </p14:section>
-        <p14:section name="Results" id="{6d987dd9-3ec6-b8a6-708c-bb0ae43a66b0}">
+        <p14:section name="Results" id="{ed72ee8d-3f04-adcf-a17c-37be7368fb1d}">
           <p14:sldIdLst>
             <p14:sldId id="264"/>
             <p14:sldId id="265"/>
           </p14:sldIdLst>
         </p14:section>
-        <p14:section name="Decision" id="{6eee5d6a-c335-6060-dad8-bd8461de6b6b}">
+        <p14:section name="Decision" id="{cdfb817d-8fd6-9a68-f629-92ac878508f5}">
           <p14:sldIdLst>
             <p14:sldId id="266"/>
             <p14:sldId id="267"/>
@@ -2605,7 +2605,7 @@
           <a:p>
             <a:r>
               <a:rPr lang="en-US" dirty="0"/>
-              <a:t>Five steps. One: a fixed dataset and split, D-Fire, where almost half the images contain no fire or smoke so that false alarms can be measured. Two: build the candidate models with the pretrained backbone frozen. Three: train each for 40 epochs with identical settings. Four: after every epoch measure accuracy and the alarm behaviour on the validation set, and keep the best epoch. Five: evaluate once on the untouched test set and decide. The rule throughout is that only one thing changes at a time.</a:t>
+              <a:t>The method in six steps. One: collect labelled images, including many with no fire, so that false alarms can be measured. Two: resize each frame and, during training, alter the images to imitate the site conditions: low light, infrared cameras, flames hidden behind objects. Three: a pretrained backbone extracts features and a pyramid makes them available at several scales. Four: a detection head outputs boxes with a class and a score, and a scene classifier gives a second opinion on the whole image for hidden fire. Five: train by transfer learning and evaluate with mAP and the false-alarm rate. Six: choose the confidence threshold for very few false alarms, and on video require repeated detections before raising an alarm.</a:t>
             </a:r>
             <a:endParaRPr lang="en-US" dirty="0"/>
           </a:p>
@@ -9453,7 +9453,7 @@
                   <a:schemeClr val="tx1"/>
                 </a:solidFill>
               </a:rPr>
-              <a:t>Methodology: how the models were compared</a:t>
+              <a:t>Methodology: how fire and smoke are detected</a:t>
             </a:r>
             <a:endParaRPr lang="en-US" sz="3000" dirty="0"/>
           </a:p>
@@ -9467,12 +9467,12 @@
         </p:nvSpPr>
         <p:spPr>
           <a:xfrm>
-            <a:off x="548640" y="1371600"/>
-            <a:ext cx="2029968" cy="3566160"/>
+            <a:off x="548640" y="1325880"/>
+            <a:ext cx="3520440" cy="1874520"/>
           </a:xfrm>
           <a:prstGeom prst="roundRect">
             <a:avLst>
-              <a:gd name="adj" fmla="val 3604"/>
+              <a:gd name="adj" fmla="val 3902"/>
             </a:avLst>
           </a:prstGeom>
           <a:solidFill>
@@ -9494,7 +9494,7 @@
         </p:nvSpPr>
         <p:spPr>
           <a:xfrm>
-            <a:off x="731520" y="1554480"/>
+            <a:off x="749808" y="1508760"/>
             <a:ext cx="420624" cy="420624"/>
           </a:xfrm>
           <a:prstGeom prst="ellipse">
@@ -9519,7 +9519,7 @@
         </p:nvSpPr>
         <p:spPr>
           <a:xfrm>
-            <a:off x="731520" y="1554480"/>
+            <a:off x="749808" y="1508760"/>
             <a:ext cx="420624" cy="420624"/>
           </a:xfrm>
           <a:prstGeom prst="rect">
@@ -9555,8 +9555,8 @@
         </p:nvSpPr>
         <p:spPr>
           <a:xfrm>
-            <a:off x="1261872" y="1554480"/>
-            <a:ext cx="1207008" cy="420624"/>
+            <a:off x="1298448" y="1508760"/>
+            <a:ext cx="2606040" cy="420624"/>
           </a:xfrm>
           <a:prstGeom prst="rect">
             <a:avLst/>
@@ -9572,14 +9572,14 @@
               <a:buNone/>
             </a:pPr>
             <a:r>
-              <a:rPr lang="en-US" sz="1800" b="1" dirty="0">
+              <a:rPr lang="en-US" sz="1700" b="1" dirty="0">
                 <a:solidFill>
                   <a:schemeClr val="tx1"/>
                 </a:solidFill>
               </a:rPr>
-              <a:t>Data</a:t>
-            </a:r>
-            <a:endParaRPr lang="en-US" sz="1800" dirty="0"/>
+              <a:t>Data collection</a:t>
+            </a:r>
+            <a:endParaRPr lang="en-US" sz="1700" dirty="0"/>
           </a:p>
         </p:txBody>
       </p:sp>
@@ -9591,8 +9591,8 @@
         </p:nvSpPr>
         <p:spPr>
           <a:xfrm>
-            <a:off x="685800" y="2240280"/>
-            <a:ext cx="1755648" cy="2560320"/>
+            <a:off x="731520" y="2057400"/>
+            <a:ext cx="3154680" cy="1051560"/>
           </a:xfrm>
           <a:prstGeom prst="rect">
             <a:avLst/>
@@ -9606,7 +9606,7 @@
           <a:p>
             <a:pPr marL="342900" indent="-342900">
               <a:spcAft>
-                <a:spcPts val="800"/>
+                <a:spcPts val="500"/>
               </a:spcAft>
               <a:buSzPct val="100000"/>
               <a:buChar char="•"/>
@@ -9617,14 +9617,14 @@
                   <a:schemeClr val="tx1"/>
                 </a:solidFill>
               </a:rPr>
-              <a:t>D-Fire dataset, 21,527 labelled images</a:t>
+              <a:t>21,527 images labelled with boxes for smoke and fire (D-Fire)</a:t>
             </a:r>
             <a:endParaRPr lang="en-US" sz="1300" dirty="0"/>
           </a:p>
           <a:p>
             <a:pPr marL="342900" indent="-342900">
               <a:spcAft>
-                <a:spcPts val="800"/>
+                <a:spcPts val="500"/>
               </a:spcAft>
               <a:buSzPct val="100000"/>
               <a:buChar char="•"/>
@@ -9635,25 +9635,7 @@
                   <a:schemeClr val="tx1"/>
                 </a:solidFill>
               </a:rPr>
-              <a:t>Fixed split: 13,776 train, 3,445 validation, 4,306 test</a:t>
-            </a:r>
-            <a:endParaRPr lang="en-US" sz="1300" dirty="0"/>
-          </a:p>
-          <a:p>
-            <a:pPr marL="342900" indent="-342900">
-              <a:spcAft>
-                <a:spcPts val="800"/>
-              </a:spcAft>
-              <a:buSzPct val="100000"/>
-              <a:buChar char="•"/>
-            </a:pPr>
-            <a:r>
-              <a:rPr lang="en-US" sz="1300" dirty="0">
-                <a:solidFill>
-                  <a:schemeClr val="tx1"/>
-                </a:solidFill>
-              </a:rPr>
-              <a:t>45% of images contain no fire or smoke</a:t>
+              <a:t>45% show no fire or smoke, so false alarms can be measured</a:t>
             </a:r>
             <a:endParaRPr lang="en-US" sz="1300" dirty="0"/>
           </a:p>
@@ -9667,8 +9649,8 @@
         </p:nvSpPr>
         <p:spPr>
           <a:xfrm>
-            <a:off x="2606040" y="1764792"/>
-            <a:ext cx="173736" cy="0"/>
+            <a:off x="4096512" y="1719072"/>
+            <a:ext cx="196596" cy="0"/>
           </a:xfrm>
           <a:prstGeom prst="line">
             <a:avLst/>
@@ -9691,12 +9673,12 @@
         </p:nvSpPr>
         <p:spPr>
           <a:xfrm>
-            <a:off x="2807208" y="1371600"/>
-            <a:ext cx="2029968" cy="3566160"/>
+            <a:off x="4320540" y="1325880"/>
+            <a:ext cx="3520440" cy="1874520"/>
           </a:xfrm>
           <a:prstGeom prst="roundRect">
             <a:avLst>
-              <a:gd name="adj" fmla="val 3604"/>
+              <a:gd name="adj" fmla="val 3902"/>
             </a:avLst>
           </a:prstGeom>
           <a:solidFill>
@@ -9718,7 +9700,7 @@
         </p:nvSpPr>
         <p:spPr>
           <a:xfrm>
-            <a:off x="2990088" y="1554480"/>
+            <a:off x="4521708" y="1508760"/>
             <a:ext cx="420624" cy="420624"/>
           </a:xfrm>
           <a:prstGeom prst="ellipse">
@@ -9743,7 +9725,7 @@
         </p:nvSpPr>
         <p:spPr>
           <a:xfrm>
-            <a:off x="2990088" y="1554480"/>
+            <a:off x="4521708" y="1508760"/>
             <a:ext cx="420624" cy="420624"/>
           </a:xfrm>
           <a:prstGeom prst="rect">
@@ -9779,8 +9761,8 @@
         </p:nvSpPr>
         <p:spPr>
           <a:xfrm>
-            <a:off x="3520440" y="1554480"/>
-            <a:ext cx="1207008" cy="420624"/>
+            <a:off x="5070348" y="1508760"/>
+            <a:ext cx="2606040" cy="420624"/>
           </a:xfrm>
           <a:prstGeom prst="rect">
             <a:avLst/>
@@ -9796,14 +9778,14 @@
               <a:buNone/>
             </a:pPr>
             <a:r>
-              <a:rPr lang="en-US" sz="1800" b="1" dirty="0">
+              <a:rPr lang="en-US" sz="1700" b="1" dirty="0">
                 <a:solidFill>
                   <a:schemeClr val="tx1"/>
                 </a:solidFill>
               </a:rPr>
-              <a:t>Models</a:t>
-            </a:r>
-            <a:endParaRPr lang="en-US" sz="1800" dirty="0"/>
+              <a:t>Pre-processing</a:t>
+            </a:r>
+            <a:endParaRPr lang="en-US" sz="1700" dirty="0"/>
           </a:p>
         </p:txBody>
       </p:sp>
@@ -9815,8 +9797,8 @@
         </p:nvSpPr>
         <p:spPr>
           <a:xfrm>
-            <a:off x="2944368" y="2240280"/>
-            <a:ext cx="1755648" cy="2560320"/>
+            <a:off x="4503420" y="2057400"/>
+            <a:ext cx="3154680" cy="1051560"/>
           </a:xfrm>
           <a:prstGeom prst="rect">
             <a:avLst/>
@@ -9830,7 +9812,7 @@
           <a:p>
             <a:pPr marL="342900" indent="-342900">
               <a:spcAft>
-                <a:spcPts val="800"/>
+                <a:spcPts val="500"/>
               </a:spcAft>
               <a:buSzPct val="100000"/>
               <a:buChar char="•"/>
@@ -9841,14 +9823,14 @@
                   <a:schemeClr val="tx1"/>
                 </a:solidFill>
               </a:rPr>
-              <a:t>3 backbones, each with Faster R-CNN</a:t>
+              <a:t>Each frame resized to 640 x 640, shape kept</a:t>
             </a:r>
             <a:endParaRPr lang="en-US" sz="1300" dirty="0"/>
           </a:p>
           <a:p>
             <a:pPr marL="342900" indent="-342900">
               <a:spcAft>
-                <a:spcPts val="800"/>
+                <a:spcPts val="500"/>
               </a:spcAft>
               <a:buSzPct val="100000"/>
               <a:buChar char="•"/>
@@ -9859,25 +9841,7 @@
                   <a:schemeClr val="tx1"/>
                 </a:solidFill>
               </a:rPr>
-              <a:t>1 lighter model with FCOS</a:t>
-            </a:r>
-            <a:endParaRPr lang="en-US" sz="1300" dirty="0"/>
-          </a:p>
-          <a:p>
-            <a:pPr marL="342900" indent="-342900">
-              <a:spcAft>
-                <a:spcPts val="800"/>
-              </a:spcAft>
-              <a:buSzPct val="100000"/>
-              <a:buChar char="•"/>
-            </a:pPr>
-            <a:r>
-              <a:rPr lang="en-US" sz="1300" dirty="0">
-                <a:solidFill>
-                  <a:schemeClr val="tx1"/>
-                </a:solidFill>
-              </a:rPr>
-              <a:t>Pretrained backbone kept frozen</a:t>
+              <a:t>Training images imitate low light, infrared and hidden flames</a:t>
             </a:r>
             <a:endParaRPr lang="en-US" sz="1300" dirty="0"/>
           </a:p>
@@ -9891,8 +9855,8 @@
         </p:nvSpPr>
         <p:spPr>
           <a:xfrm>
-            <a:off x="4864608" y="1764792"/>
-            <a:ext cx="173736" cy="0"/>
+            <a:off x="7868412" y="1719072"/>
+            <a:ext cx="196596" cy="0"/>
           </a:xfrm>
           <a:prstGeom prst="line">
             <a:avLst/>
@@ -9915,12 +9879,12 @@
         </p:nvSpPr>
         <p:spPr>
           <a:xfrm>
-            <a:off x="5065776" y="1371600"/>
-            <a:ext cx="2029968" cy="3566160"/>
+            <a:off x="8092440" y="1325880"/>
+            <a:ext cx="3520440" cy="1874520"/>
           </a:xfrm>
           <a:prstGeom prst="roundRect">
             <a:avLst>
-              <a:gd name="adj" fmla="val 3604"/>
+              <a:gd name="adj" fmla="val 3902"/>
             </a:avLst>
           </a:prstGeom>
           <a:solidFill>
@@ -9942,7 +9906,7 @@
         </p:nvSpPr>
         <p:spPr>
           <a:xfrm>
-            <a:off x="5248656" y="1554480"/>
+            <a:off x="8293608" y="1508760"/>
             <a:ext cx="420624" cy="420624"/>
           </a:xfrm>
           <a:prstGeom prst="ellipse">
@@ -9967,7 +9931,7 @@
         </p:nvSpPr>
         <p:spPr>
           <a:xfrm>
-            <a:off x="5248656" y="1554480"/>
+            <a:off x="8293608" y="1508760"/>
             <a:ext cx="420624" cy="420624"/>
           </a:xfrm>
           <a:prstGeom prst="rect">
@@ -10003,8 +9967,8 @@
         </p:nvSpPr>
         <p:spPr>
           <a:xfrm>
-            <a:off x="5779008" y="1554480"/>
-            <a:ext cx="1207008" cy="420624"/>
+            <a:off x="8842248" y="1508760"/>
+            <a:ext cx="2606040" cy="420624"/>
           </a:xfrm>
           <a:prstGeom prst="rect">
             <a:avLst/>
@@ -10020,14 +9984,14 @@
               <a:buNone/>
             </a:pPr>
             <a:r>
-              <a:rPr lang="en-US" sz="1800" b="1" dirty="0">
+              <a:rPr lang="en-US" sz="1700" b="1" dirty="0">
                 <a:solidFill>
                   <a:schemeClr val="tx1"/>
                 </a:solidFill>
               </a:rPr>
-              <a:t>Training</a:t>
-            </a:r>
-            <a:endParaRPr lang="en-US" sz="1800" dirty="0"/>
+              <a:t>Feature extraction</a:t>
+            </a:r>
+            <a:endParaRPr lang="en-US" sz="1700" dirty="0"/>
           </a:p>
         </p:txBody>
       </p:sp>
@@ -10039,8 +10003,8 @@
         </p:nvSpPr>
         <p:spPr>
           <a:xfrm>
-            <a:off x="5202936" y="2240280"/>
-            <a:ext cx="1755648" cy="2560320"/>
+            <a:off x="8275320" y="2057400"/>
+            <a:ext cx="3154680" cy="1051560"/>
           </a:xfrm>
           <a:prstGeom prst="rect">
             <a:avLst/>
@@ -10054,7 +10018,7 @@
           <a:p>
             <a:pPr marL="342900" indent="-342900">
               <a:spcAft>
-                <a:spcPts val="800"/>
+                <a:spcPts val="500"/>
               </a:spcAft>
               <a:buSzPct val="100000"/>
               <a:buChar char="•"/>
@@ -10065,14 +10029,14 @@
                   <a:schemeClr val="tx1"/>
                 </a:solidFill>
               </a:rPr>
-              <a:t>40 epochs for every model</a:t>
+              <a:t>A pretrained backbone turns the image into features</a:t>
             </a:r>
             <a:endParaRPr lang="en-US" sz="1300" dirty="0"/>
           </a:p>
           <a:p>
             <a:pPr marL="342900" indent="-342900">
               <a:spcAft>
-                <a:spcPts val="800"/>
+                <a:spcPts val="500"/>
               </a:spcAft>
               <a:buSzPct val="100000"/>
               <a:buChar char="•"/>
@@ -10083,25 +10047,7 @@
                   <a:schemeClr val="tx1"/>
                 </a:solidFill>
               </a:rPr>
-              <a:t>AdamW, learning rate 1e-4, batch 8</a:t>
-            </a:r>
-            <a:endParaRPr lang="en-US" sz="1300" dirty="0"/>
-          </a:p>
-          <a:p>
-            <a:pPr marL="342900" indent="-342900">
-              <a:spcAft>
-                <a:spcPts val="800"/>
-              </a:spcAft>
-              <a:buSzPct val="100000"/>
-              <a:buChar char="•"/>
-            </a:pPr>
-            <a:r>
-              <a:rPr lang="en-US" sz="1300" dirty="0">
-                <a:solidFill>
-                  <a:schemeClr val="tx1"/>
-                </a:solidFill>
-              </a:rPr>
-              <a:t>Low-light, infrared-style and occlusion augmentation</a:t>
+              <a:t>A feature pyramid covers large and small fires</a:t>
             </a:r>
             <a:endParaRPr lang="en-US" sz="1300" dirty="0"/>
           </a:p>
@@ -10115,36 +10061,12 @@
         </p:nvSpPr>
         <p:spPr>
           <a:xfrm>
-            <a:off x="7123176" y="1764792"/>
-            <a:ext cx="173736" cy="0"/>
-          </a:xfrm>
-          <a:prstGeom prst="line">
-            <a:avLst/>
-          </a:prstGeom>
-          <a:noFill/>
-          <a:ln w="19050">
-            <a:solidFill>
-              <a:srgbClr val="5B6670"/>
-            </a:solidFill>
-            <a:prstDash val="solid"/>
-            <a:tailEnd type="triangle"/>
-          </a:ln>
-        </p:spPr>
-      </p:sp>
-      <p:sp>
-        <p:nvSpPr>
-          <p:cNvPr id="21" name="Shape 19"/>
-          <p:cNvSpPr/>
-          <p:nvPr/>
-        </p:nvSpPr>
-        <p:spPr>
-          <a:xfrm>
-            <a:off x="7324344" y="1371600"/>
-            <a:ext cx="2029968" cy="3566160"/>
+            <a:off x="548640" y="3383280"/>
+            <a:ext cx="3520440" cy="1874520"/>
           </a:xfrm>
           <a:prstGeom prst="roundRect">
             <a:avLst>
-              <a:gd name="adj" fmla="val 3604"/>
+              <a:gd name="adj" fmla="val 3902"/>
             </a:avLst>
           </a:prstGeom>
           <a:solidFill>
@@ -10160,13 +10082,13 @@
       </p:sp>
       <p:sp>
         <p:nvSpPr>
-          <p:cNvPr id="22" name="Shape 20"/>
+          <p:cNvPr id="21" name="Shape 19"/>
           <p:cNvSpPr/>
           <p:nvPr/>
         </p:nvSpPr>
         <p:spPr>
           <a:xfrm>
-            <a:off x="7507224" y="1554480"/>
+            <a:off x="749808" y="3566160"/>
             <a:ext cx="420624" cy="420624"/>
           </a:xfrm>
           <a:prstGeom prst="ellipse">
@@ -10185,14 +10107,50 @@
       </p:sp>
       <p:sp>
         <p:nvSpPr>
+          <p:cNvPr id="22" name="Text 20"/>
+          <p:cNvSpPr txBox="1"/>
+          <p:nvPr/>
+        </p:nvSpPr>
+        <p:spPr>
+          <a:xfrm>
+            <a:off x="749808" y="3566160"/>
+            <a:ext cx="420624" cy="420624"/>
+          </a:xfrm>
+          <a:prstGeom prst="rect">
+            <a:avLst/>
+          </a:prstGeom>
+          <a:noFill/>
+          <a:ln/>
+        </p:spPr>
+        <p:txBody>
+          <a:bodyPr wrap="square" lIns="0" tIns="0" rIns="0" bIns="0" rtlCol="0" anchor="ctr"/>
+          <a:lstStyle/>
+          <a:p>
+            <a:pPr algn="ctr" indent="0" marL="0">
+              <a:buNone/>
+            </a:pPr>
+            <a:r>
+              <a:rPr lang="en-US" sz="1500" b="1" dirty="0">
+                <a:solidFill>
+                  <a:schemeClr val="bg1"/>
+                </a:solidFill>
+              </a:rPr>
+              <a:t>4</a:t>
+            </a:r>
+            <a:endParaRPr lang="en-US" sz="1500" dirty="0"/>
+          </a:p>
+        </p:txBody>
+      </p:sp>
+      <p:sp>
+        <p:nvSpPr>
           <p:cNvPr id="23" name="Text 21"/>
           <p:cNvSpPr txBox="1"/>
           <p:nvPr/>
         </p:nvSpPr>
         <p:spPr>
           <a:xfrm>
-            <a:off x="7507224" y="1554480"/>
-            <a:ext cx="420624" cy="420624"/>
+            <a:off x="1298448" y="3566160"/>
+            <a:ext cx="2606040" cy="420624"/>
           </a:xfrm>
           <a:prstGeom prst="rect">
             <a:avLst/>
@@ -10204,18 +10162,18 @@
           <a:bodyPr wrap="square" lIns="0" tIns="0" rIns="0" bIns="0" rtlCol="0" anchor="ctr"/>
           <a:lstStyle/>
           <a:p>
-            <a:pPr algn="ctr" indent="0" marL="0">
-              <a:buNone/>
-            </a:pPr>
-            <a:r>
-              <a:rPr lang="en-US" sz="1500" b="1" dirty="0">
-                <a:solidFill>
-                  <a:schemeClr val="bg1"/>
-                </a:solidFill>
-              </a:rPr>
-              <a:t>4</a:t>
-            </a:r>
-            <a:endParaRPr lang="en-US" sz="1500" dirty="0"/>
+            <a:pPr indent="0" marL="0">
+              <a:buNone/>
+            </a:pPr>
+            <a:r>
+              <a:rPr lang="en-US" sz="1700" b="1" dirty="0">
+                <a:solidFill>
+                  <a:schemeClr val="tx1"/>
+                </a:solidFill>
+              </a:rPr>
+              <a:t>Detection</a:t>
+            </a:r>
+            <a:endParaRPr lang="en-US" sz="1700" dirty="0"/>
           </a:p>
         </p:txBody>
       </p:sp>
@@ -10227,44 +10185,8 @@
         </p:nvSpPr>
         <p:spPr>
           <a:xfrm>
-            <a:off x="8037576" y="1554480"/>
-            <a:ext cx="1207008" cy="420624"/>
-          </a:xfrm>
-          <a:prstGeom prst="rect">
-            <a:avLst/>
-          </a:prstGeom>
-          <a:noFill/>
-          <a:ln/>
-        </p:spPr>
-        <p:txBody>
-          <a:bodyPr wrap="square" lIns="0" tIns="0" rIns="0" bIns="0" rtlCol="0" anchor="ctr"/>
-          <a:lstStyle/>
-          <a:p>
-            <a:pPr indent="0" marL="0">
-              <a:buNone/>
-            </a:pPr>
-            <a:r>
-              <a:rPr lang="en-US" sz="1800" b="1" dirty="0">
-                <a:solidFill>
-                  <a:schemeClr val="tx1"/>
-                </a:solidFill>
-              </a:rPr>
-              <a:t>Evaluation</a:t>
-            </a:r>
-            <a:endParaRPr lang="en-US" sz="1800" dirty="0"/>
-          </a:p>
-        </p:txBody>
-      </p:sp>
-      <p:sp>
-        <p:nvSpPr>
-          <p:cNvPr id="25" name="Text 23"/>
-          <p:cNvSpPr txBox="1"/>
-          <p:nvPr/>
-        </p:nvSpPr>
-        <p:spPr>
-          <a:xfrm>
-            <a:off x="7461504" y="2240280"/>
-            <a:ext cx="1755648" cy="2560320"/>
+            <a:off x="731520" y="4114800"/>
+            <a:ext cx="3154680" cy="1051560"/>
           </a:xfrm>
           <a:prstGeom prst="rect">
             <a:avLst/>
@@ -10278,7 +10200,7 @@
           <a:p>
             <a:pPr marL="342900" indent="-342900">
               <a:spcAft>
-                <a:spcPts val="800"/>
+                <a:spcPts val="500"/>
               </a:spcAft>
               <a:buSzPct val="100000"/>
               <a:buChar char="•"/>
@@ -10289,14 +10211,14 @@
                   <a:schemeClr val="tx1"/>
                 </a:solidFill>
               </a:rPr>
-              <a:t>After every epoch, on validation</a:t>
+              <a:t>Detection head: box, class (smoke or fire) and confidence score</a:t>
             </a:r>
             <a:endParaRPr lang="en-US" sz="1300" dirty="0"/>
           </a:p>
           <a:p>
             <a:pPr marL="342900" indent="-342900">
               <a:spcAft>
-                <a:spcPts val="800"/>
+                <a:spcPts val="500"/>
               </a:spcAft>
               <a:buSzPct val="100000"/>
               <a:buChar char="•"/>
@@ -10307,40 +10229,22 @@
                   <a:schemeClr val="tx1"/>
                 </a:solidFill>
               </a:rPr>
-              <a:t>AP for smoke and fire, mAP@0.5</a:t>
+              <a:t>Scene classifier: whole-image check for a hidden fire's glow</a:t>
             </a:r>
             <a:endParaRPr lang="en-US" sz="1300" dirty="0"/>
           </a:p>
-          <a:p>
-            <a:pPr marL="342900" indent="-342900">
-              <a:spcAft>
-                <a:spcPts val="800"/>
-              </a:spcAft>
-              <a:buSzPct val="100000"/>
-              <a:buChar char="•"/>
-            </a:pPr>
-            <a:r>
-              <a:rPr lang="en-US" sz="1300" dirty="0">
-                <a:solidFill>
-                  <a:schemeClr val="tx1"/>
-                </a:solidFill>
-              </a:rPr>
-              <a:t>Detections at no more than 1% false alarms</a:t>
-            </a:r>
-            <a:endParaRPr lang="en-US" sz="1300" dirty="0"/>
-          </a:p>
-        </p:txBody>
-      </p:sp>
-      <p:sp>
-        <p:nvSpPr>
-          <p:cNvPr id="26" name="Shape 24"/>
+        </p:txBody>
+      </p:sp>
+      <p:sp>
+        <p:nvSpPr>
+          <p:cNvPr id="25" name="Shape 23"/>
           <p:cNvSpPr/>
           <p:nvPr/>
         </p:nvSpPr>
         <p:spPr>
           <a:xfrm>
-            <a:off x="9381744" y="1764792"/>
-            <a:ext cx="173736" cy="0"/>
+            <a:off x="4096512" y="3776472"/>
+            <a:ext cx="196596" cy="0"/>
           </a:xfrm>
           <a:prstGeom prst="line">
             <a:avLst/>
@@ -10357,18 +10261,18 @@
       </p:sp>
       <p:sp>
         <p:nvSpPr>
-          <p:cNvPr id="27" name="Shape 25"/>
+          <p:cNvPr id="26" name="Shape 24"/>
           <p:cNvSpPr/>
           <p:nvPr/>
         </p:nvSpPr>
         <p:spPr>
           <a:xfrm>
-            <a:off x="9582912" y="1371600"/>
-            <a:ext cx="2029968" cy="3566160"/>
+            <a:off x="4320540" y="3383280"/>
+            <a:ext cx="3520440" cy="1874520"/>
           </a:xfrm>
           <a:prstGeom prst="roundRect">
             <a:avLst>
-              <a:gd name="adj" fmla="val 3604"/>
+              <a:gd name="adj" fmla="val 3902"/>
             </a:avLst>
           </a:prstGeom>
           <a:solidFill>
@@ -10384,13 +10288,13 @@
       </p:sp>
       <p:sp>
         <p:nvSpPr>
-          <p:cNvPr id="28" name="Shape 26"/>
+          <p:cNvPr id="27" name="Shape 25"/>
           <p:cNvSpPr/>
           <p:nvPr/>
         </p:nvSpPr>
         <p:spPr>
           <a:xfrm>
-            <a:off x="9765792" y="1554480"/>
+            <a:off x="4521708" y="3566160"/>
             <a:ext cx="420624" cy="420624"/>
           </a:xfrm>
           <a:prstGeom prst="ellipse">
@@ -10409,14 +10313,50 @@
       </p:sp>
       <p:sp>
         <p:nvSpPr>
+          <p:cNvPr id="28" name="Text 26"/>
+          <p:cNvSpPr txBox="1"/>
+          <p:nvPr/>
+        </p:nvSpPr>
+        <p:spPr>
+          <a:xfrm>
+            <a:off x="4521708" y="3566160"/>
+            <a:ext cx="420624" cy="420624"/>
+          </a:xfrm>
+          <a:prstGeom prst="rect">
+            <a:avLst/>
+          </a:prstGeom>
+          <a:noFill/>
+          <a:ln/>
+        </p:spPr>
+        <p:txBody>
+          <a:bodyPr wrap="square" lIns="0" tIns="0" rIns="0" bIns="0" rtlCol="0" anchor="ctr"/>
+          <a:lstStyle/>
+          <a:p>
+            <a:pPr algn="ctr" indent="0" marL="0">
+              <a:buNone/>
+            </a:pPr>
+            <a:r>
+              <a:rPr lang="en-US" sz="1500" b="1" dirty="0">
+                <a:solidFill>
+                  <a:schemeClr val="bg1"/>
+                </a:solidFill>
+              </a:rPr>
+              <a:t>5</a:t>
+            </a:r>
+            <a:endParaRPr lang="en-US" sz="1500" dirty="0"/>
+          </a:p>
+        </p:txBody>
+      </p:sp>
+      <p:sp>
+        <p:nvSpPr>
           <p:cNvPr id="29" name="Text 27"/>
           <p:cNvSpPr txBox="1"/>
           <p:nvPr/>
         </p:nvSpPr>
         <p:spPr>
           <a:xfrm>
-            <a:off x="9765792" y="1554480"/>
-            <a:ext cx="420624" cy="420624"/>
+            <a:off x="5070348" y="3566160"/>
+            <a:ext cx="2606040" cy="420624"/>
           </a:xfrm>
           <a:prstGeom prst="rect">
             <a:avLst/>
@@ -10428,18 +10368,18 @@
           <a:bodyPr wrap="square" lIns="0" tIns="0" rIns="0" bIns="0" rtlCol="0" anchor="ctr"/>
           <a:lstStyle/>
           <a:p>
-            <a:pPr algn="ctr" indent="0" marL="0">
-              <a:buNone/>
-            </a:pPr>
-            <a:r>
-              <a:rPr lang="en-US" sz="1500" b="1" dirty="0">
-                <a:solidFill>
-                  <a:schemeClr val="bg1"/>
-                </a:solidFill>
-              </a:rPr>
-              <a:t>5</a:t>
-            </a:r>
-            <a:endParaRPr lang="en-US" sz="1500" dirty="0"/>
+            <a:pPr indent="0" marL="0">
+              <a:buNone/>
+            </a:pPr>
+            <a:r>
+              <a:rPr lang="en-US" sz="1700" b="1" dirty="0">
+                <a:solidFill>
+                  <a:schemeClr val="tx1"/>
+                </a:solidFill>
+              </a:rPr>
+              <a:t>Train and evaluate</a:t>
+            </a:r>
+            <a:endParaRPr lang="en-US" sz="1700" dirty="0"/>
           </a:p>
         </p:txBody>
       </p:sp>
@@ -10451,44 +10391,8 @@
         </p:nvSpPr>
         <p:spPr>
           <a:xfrm>
-            <a:off x="10296144" y="1554480"/>
-            <a:ext cx="1207008" cy="420624"/>
-          </a:xfrm>
-          <a:prstGeom prst="rect">
-            <a:avLst/>
-          </a:prstGeom>
-          <a:noFill/>
-          <a:ln/>
-        </p:spPr>
-        <p:txBody>
-          <a:bodyPr wrap="square" lIns="0" tIns="0" rIns="0" bIns="0" rtlCol="0" anchor="ctr"/>
-          <a:lstStyle/>
-          <a:p>
-            <a:pPr indent="0" marL="0">
-              <a:buNone/>
-            </a:pPr>
-            <a:r>
-              <a:rPr lang="en-US" sz="1800" b="1" dirty="0">
-                <a:solidFill>
-                  <a:schemeClr val="tx1"/>
-                </a:solidFill>
-              </a:rPr>
-              <a:t>Decision</a:t>
-            </a:r>
-            <a:endParaRPr lang="en-US" sz="1800" dirty="0"/>
-          </a:p>
-        </p:txBody>
-      </p:sp>
-      <p:sp>
-        <p:nvSpPr>
-          <p:cNvPr id="31" name="Text 29"/>
-          <p:cNvSpPr txBox="1"/>
-          <p:nvPr/>
-        </p:nvSpPr>
-        <p:spPr>
-          <a:xfrm>
-            <a:off x="9720072" y="2240280"/>
-            <a:ext cx="1755648" cy="2560320"/>
+            <a:off x="4503420" y="4114800"/>
+            <a:ext cx="3154680" cy="1051560"/>
           </a:xfrm>
           <a:prstGeom prst="rect">
             <a:avLst/>
@@ -10502,7 +10406,7 @@
           <a:p>
             <a:pPr marL="342900" indent="-342900">
               <a:spcAft>
-                <a:spcPts val="800"/>
+                <a:spcPts val="500"/>
               </a:spcAft>
               <a:buSzPct val="100000"/>
               <a:buChar char="•"/>
@@ -10513,14 +10417,14 @@
                   <a:schemeClr val="tx1"/>
                 </a:solidFill>
               </a:rPr>
-              <a:t>Test set used once, at the end</a:t>
+              <a:t>Transfer learning on the fire data; best epoch kept</a:t>
             </a:r>
             <a:endParaRPr lang="en-US" sz="1300" dirty="0"/>
           </a:p>
           <a:p>
             <a:pPr marL="342900" indent="-342900">
               <a:spcAft>
-                <a:spcPts val="800"/>
+                <a:spcPts val="500"/>
               </a:spcAft>
               <a:buSzPct val="100000"/>
               <a:buChar char="•"/>
@@ -10531,29 +10435,35 @@
                   <a:schemeClr val="tx1"/>
                 </a:solidFill>
               </a:rPr>
-              <a:t>Compare accuracy, false alarms, speed, size</a:t>
+              <a:t>Measured by mAP@0.5 and the false-alarm rate</a:t>
             </a:r>
             <a:endParaRPr lang="en-US" sz="1300" dirty="0"/>
           </a:p>
-          <a:p>
-            <a:pPr marL="342900" indent="-342900">
-              <a:spcAft>
-                <a:spcPts val="800"/>
-              </a:spcAft>
-              <a:buSzPct val="100000"/>
-              <a:buChar char="•"/>
-            </a:pPr>
-            <a:r>
-              <a:rPr lang="en-US" sz="1300" dirty="0">
-                <a:solidFill>
-                  <a:schemeClr val="tx1"/>
-                </a:solidFill>
-              </a:rPr>
-              <a:t>Choose the model to continue with</a:t>
-            </a:r>
-            <a:endParaRPr lang="en-US" sz="1300" dirty="0"/>
-          </a:p>
-        </p:txBody>
+        </p:txBody>
+      </p:sp>
+      <p:sp>
+        <p:nvSpPr>
+          <p:cNvPr id="31" name="Shape 29"/>
+          <p:cNvSpPr/>
+          <p:nvPr/>
+        </p:nvSpPr>
+        <p:spPr>
+          <a:xfrm>
+            <a:off x="7868412" y="3776472"/>
+            <a:ext cx="196596" cy="0"/>
+          </a:xfrm>
+          <a:prstGeom prst="line">
+            <a:avLst/>
+          </a:prstGeom>
+          <a:noFill/>
+          <a:ln w="19050">
+            <a:solidFill>
+              <a:srgbClr val="5B6670"/>
+            </a:solidFill>
+            <a:prstDash val="solid"/>
+            <a:tailEnd type="triangle"/>
+          </a:ln>
+        </p:spPr>
       </p:sp>
       <p:sp>
         <p:nvSpPr>
@@ -10563,12 +10473,12 @@
         </p:nvSpPr>
         <p:spPr>
           <a:xfrm>
-            <a:off x="548640" y="5212080"/>
-            <a:ext cx="11064240" cy="960120"/>
+            <a:off x="8092440" y="3383280"/>
+            <a:ext cx="3520440" cy="1874520"/>
           </a:xfrm>
           <a:prstGeom prst="roundRect">
             <a:avLst>
-              <a:gd name="adj" fmla="val 7619"/>
+              <a:gd name="adj" fmla="val 3902"/>
             </a:avLst>
           </a:prstGeom>
           <a:solidFill>
@@ -10584,14 +10494,39 @@
       </p:sp>
       <p:sp>
         <p:nvSpPr>
-          <p:cNvPr id="33" name="Text 31"/>
+          <p:cNvPr id="33" name="Shape 31"/>
+          <p:cNvSpPr/>
+          <p:nvPr/>
+        </p:nvSpPr>
+        <p:spPr>
+          <a:xfrm>
+            <a:off x="8293608" y="3566160"/>
+            <a:ext cx="420624" cy="420624"/>
+          </a:xfrm>
+          <a:prstGeom prst="ellipse">
+            <a:avLst/>
+          </a:prstGeom>
+          <a:solidFill>
+            <a:schemeClr val="accent1"/>
+          </a:solidFill>
+          <a:ln w="12700">
+            <a:solidFill>
+              <a:schemeClr val="accent1"/>
+            </a:solidFill>
+            <a:prstDash val="solid"/>
+          </a:ln>
+        </p:spPr>
+      </p:sp>
+      <p:sp>
+        <p:nvSpPr>
+          <p:cNvPr id="34" name="Text 32"/>
           <p:cNvSpPr txBox="1"/>
           <p:nvPr/>
         </p:nvSpPr>
         <p:spPr>
           <a:xfrm>
-            <a:off x="777240" y="5257800"/>
-            <a:ext cx="10607040" cy="868680"/>
+            <a:off x="8293608" y="3566160"/>
+            <a:ext cx="420624" cy="420624"/>
           </a:xfrm>
           <a:prstGeom prst="rect">
             <a:avLst/>
@@ -10603,29 +10538,208 @@
           <a:bodyPr wrap="square" lIns="0" tIns="0" rIns="0" bIns="0" rtlCol="0" anchor="ctr"/>
           <a:lstStyle/>
           <a:p>
+            <a:pPr algn="ctr" indent="0" marL="0">
+              <a:buNone/>
+            </a:pPr>
+            <a:r>
+              <a:rPr lang="en-US" sz="1500" b="1" dirty="0">
+                <a:solidFill>
+                  <a:schemeClr val="bg1"/>
+                </a:solidFill>
+              </a:rPr>
+              <a:t>6</a:t>
+            </a:r>
+            <a:endParaRPr lang="en-US" sz="1500" dirty="0"/>
+          </a:p>
+        </p:txBody>
+      </p:sp>
+      <p:sp>
+        <p:nvSpPr>
+          <p:cNvPr id="35" name="Text 33"/>
+          <p:cNvSpPr txBox="1"/>
+          <p:nvPr/>
+        </p:nvSpPr>
+        <p:spPr>
+          <a:xfrm>
+            <a:off x="8842248" y="3566160"/>
+            <a:ext cx="2606040" cy="420624"/>
+          </a:xfrm>
+          <a:prstGeom prst="rect">
+            <a:avLst/>
+          </a:prstGeom>
+          <a:noFill/>
+          <a:ln/>
+        </p:spPr>
+        <p:txBody>
+          <a:bodyPr wrap="square" lIns="0" tIns="0" rIns="0" bIns="0" rtlCol="0" anchor="ctr"/>
+          <a:lstStyle/>
+          <a:p>
             <a:pPr indent="0" marL="0">
               <a:buNone/>
             </a:pPr>
             <a:r>
-              <a:rPr lang="en-US" sz="1400" b="1" dirty="0">
+              <a:rPr lang="en-US" sz="1700" b="1" dirty="0">
+                <a:solidFill>
+                  <a:schemeClr val="tx1"/>
+                </a:solidFill>
+              </a:rPr>
+              <a:t>Alarm decision</a:t>
+            </a:r>
+            <a:endParaRPr lang="en-US" sz="1700" dirty="0"/>
+          </a:p>
+        </p:txBody>
+      </p:sp>
+      <p:sp>
+        <p:nvSpPr>
+          <p:cNvPr id="36" name="Text 34"/>
+          <p:cNvSpPr txBox="1"/>
+          <p:nvPr/>
+        </p:nvSpPr>
+        <p:spPr>
+          <a:xfrm>
+            <a:off x="8275320" y="4114800"/>
+            <a:ext cx="3154680" cy="1051560"/>
+          </a:xfrm>
+          <a:prstGeom prst="rect">
+            <a:avLst/>
+          </a:prstGeom>
+          <a:noFill/>
+          <a:ln/>
+        </p:spPr>
+        <p:txBody>
+          <a:bodyPr wrap="square" lIns="0" tIns="0" rIns="0" bIns="0" rtlCol="0" anchor="t"/>
+          <a:lstStyle/>
+          <a:p>
+            <a:pPr marL="342900" indent="-342900">
+              <a:spcAft>
+                <a:spcPts val="500"/>
+              </a:spcAft>
+              <a:buSzPct val="100000"/>
+              <a:buChar char="•"/>
+            </a:pPr>
+            <a:r>
+              <a:rPr lang="en-US" sz="1300" dirty="0">
+                <a:solidFill>
+                  <a:schemeClr val="tx1"/>
+                </a:solidFill>
+              </a:rPr>
+              <a:t>Confidence threshold set for at most 1% false alarms</a:t>
+            </a:r>
+            <a:endParaRPr lang="en-US" sz="1300" dirty="0"/>
+          </a:p>
+          <a:p>
+            <a:pPr marL="342900" indent="-342900">
+              <a:spcAft>
+                <a:spcPts val="500"/>
+              </a:spcAft>
+              <a:buSzPct val="100000"/>
+              <a:buChar char="•"/>
+            </a:pPr>
+            <a:r>
+              <a:rPr lang="en-US" sz="1300" dirty="0">
+                <a:solidFill>
+                  <a:schemeClr val="tx1"/>
+                </a:solidFill>
+              </a:rPr>
+              <a:t>On video, an alarm needs 6 detections in 15 frames</a:t>
+            </a:r>
+            <a:endParaRPr lang="en-US" sz="1300" dirty="0"/>
+          </a:p>
+        </p:txBody>
+      </p:sp>
+      <p:sp>
+        <p:nvSpPr>
+          <p:cNvPr id="37" name="Shape 35"/>
+          <p:cNvSpPr/>
+          <p:nvPr/>
+        </p:nvSpPr>
+        <p:spPr>
+          <a:xfrm>
+            <a:off x="548640" y="5440680"/>
+            <a:ext cx="11064240" cy="731520"/>
+          </a:xfrm>
+          <a:prstGeom prst="roundRect">
+            <a:avLst>
+              <a:gd name="adj" fmla="val 10000"/>
+            </a:avLst>
+          </a:prstGeom>
+          <a:solidFill>
+            <a:schemeClr val="bg2"/>
+          </a:solidFill>
+          <a:ln w="9525">
+            <a:solidFill>
+              <a:srgbClr val="D5DAE0"/>
+            </a:solidFill>
+            <a:prstDash val="solid"/>
+          </a:ln>
+        </p:spPr>
+      </p:sp>
+      <p:sp>
+        <p:nvSpPr>
+          <p:cNvPr id="38" name="Text 36"/>
+          <p:cNvSpPr txBox="1"/>
+          <p:nvPr/>
+        </p:nvSpPr>
+        <p:spPr>
+          <a:xfrm>
+            <a:off x="777240" y="5440680"/>
+            <a:ext cx="10607040" cy="731520"/>
+          </a:xfrm>
+          <a:prstGeom prst="rect">
+            <a:avLst/>
+          </a:prstGeom>
+          <a:noFill/>
+          <a:ln/>
+        </p:spPr>
+        <p:txBody>
+          <a:bodyPr wrap="square" lIns="0" tIns="0" rIns="0" bIns="0" rtlCol="0" anchor="ctr"/>
+          <a:lstStyle/>
+          <a:p>
+            <a:pPr indent="0" marL="0">
+              <a:buNone/>
+            </a:pPr>
+            <a:r>
+              <a:rPr lang="en-US" sz="1500" b="1" dirty="0">
                 <a:solidFill>
                   <a:schemeClr val="accent1"/>
                 </a:solidFill>
               </a:rPr>
-              <a:t>Rule for a fair comparison:  </a:t>
+              <a:t>Input:  </a:t>
             </a:r>
             <a:pPr indent="0" marL="0">
               <a:buNone/>
             </a:pPr>
             <a:r>
-              <a:rPr lang="en-US" sz="1400" dirty="0">
+              <a:rPr lang="en-US" sz="1500" dirty="0">
                 <a:solidFill>
                   <a:schemeClr val="tx1"/>
                 </a:solidFill>
               </a:rPr>
-              <a:t>only the part being compared changes. Data, split, augmentation, training settings and measurements are identical for every model, so a difference in results comes from the model.</a:t>
-            </a:r>
-            <a:endParaRPr lang="en-US" sz="1400" dirty="0"/>
+              <a:t>a camera frame          </a:t>
+            </a:r>
+            <a:pPr indent="0" marL="0">
+              <a:buNone/>
+            </a:pPr>
+            <a:r>
+              <a:rPr lang="en-US" sz="1500" b="1" dirty="0">
+                <a:solidFill>
+                  <a:schemeClr val="accent1"/>
+                </a:solidFill>
+              </a:rPr>
+              <a:t>Output:  </a:t>
+            </a:r>
+            <a:pPr indent="0" marL="0">
+              <a:buNone/>
+            </a:pPr>
+            <a:r>
+              <a:rPr lang="en-US" sz="1500" dirty="0">
+                <a:solidFill>
+                  <a:schemeClr val="tx1"/>
+                </a:solidFill>
+              </a:rPr>
+              <a:t>where the smoke or fire is, how confident the system is, and whether to raise an alarm</a:t>
+            </a:r>
+            <a:endParaRPr lang="en-US" sz="1500" dirty="0"/>
           </a:p>
         </p:txBody>
       </p:sp>

</xml_diff>

<commit_message>
Stage-1 deck: add complete-structure slide and problems-and-solutions slide
Co-Authored-By: Claude Opus 5.5 <noreply@anthropic.com>
</commit_message>
<xml_diff>
--- a/reports/Stage1_Model_Selection_Slides.pptx
+++ b/reports/Stage1_Model_Selection_Slides.pptx
@@ -17,9 +17,11 @@
     <p:sldId id="265" r:id="rId11"/>
     <p:sldId id="266" r:id="rId12"/>
     <p:sldId id="267" r:id="rId13"/>
+    <p:sldId id="268" r:id="rId14"/>
+    <p:sldId id="269" r:id="rId15"/>
   </p:sldIdLst>
   <p:notesMasterIdLst>
-    <p:notesMasterId r:id="rId14"/>
+    <p:notesMasterId r:id="rId16"/>
   </p:notesMasterIdLst>
   <p:sldSz cx="12192000" cy="6858000"/>
   <p:notesSz cx="6858000" cy="12192000"/>
@@ -118,13 +120,13 @@
   <p:extLst>
     <p:ext uri="{521415D9-36F7-43E2-AB2F-B90AF26B5E84}">
       <p14:sectionLst xmlns:p14="http://schemas.microsoft.com/office/powerpoint/2010/main">
-        <p14:section name="Introduction" id="{2c0c908e-17a2-ab44-7853-c5474073c9b0}">
+        <p14:section name="Introduction" id="{d869692c-5fef-5c76-eafd-69488d308cff}">
           <p14:sldIdLst>
             <p14:sldId id="256"/>
             <p14:sldId id="257"/>
           </p14:sldIdLst>
         </p14:section>
-        <p14:section name="Models" id="{cb0d21e4-4ed9-c85a-7795-fca6f7d3ce2b}">
+        <p14:section name="Models" id="{c1929578-24cf-208c-b3a0-e21242c89ffa}">
           <p14:sldIdLst>
             <p14:sldId id="258"/>
             <p14:sldId id="259"/>
@@ -134,16 +136,18 @@
             <p14:sldId id="263"/>
           </p14:sldIdLst>
         </p14:section>
-        <p14:section name="Results" id="{ed72ee8d-3f04-adcf-a17c-37be7368fb1d}">
+        <p14:section name="Results" id="{1c32a341-b579-8480-5805-01ea64a67183}">
           <p14:sldIdLst>
             <p14:sldId id="264"/>
             <p14:sldId id="265"/>
           </p14:sldIdLst>
         </p14:section>
-        <p14:section name="Decision" id="{cdfb817d-8fd6-9a68-f629-92ac878508f5}">
+        <p14:section name="Decision" id="{e416077b-6435-1570-9837-a280de4370ee}">
           <p14:sldIdLst>
             <p14:sldId id="266"/>
             <p14:sldId id="267"/>
+            <p14:sldId id="268"/>
+            <p14:sldId id="269"/>
           </p14:sldIdLst>
         </p14:section>
       </p14:sectionLst>
@@ -2341,7 +2345,7 @@
           <a:p>
             <a:r>
               <a:rPr lang="en-US" dirty="0"/>
-              <a:t>The plan from here. First fine-tune part of the DINOv3 backbone at a low learning rate, which is where overfitting must be watched. Then small and distant fires, hard negatives to push false alarms down, testing on video, a fast version for the 70-camera requirement, and data from the site's own cameras. The full report has the results of every epoch for every model.</a:t>
+              <a:t>The full structure of the model we continue with, top to bottom. The frame is resized to 640 by 640. DINOv3 turns it into 1,600 tokens and processes them through 12 transformer blocks; this part has 21.6 million parameters and is frozen. A feature pyramid produces four scales. Then two outputs work side by side: the Faster R-CNN head gives boxes with a class and a score, and the scene classifier gives a whole-image probability for smoke and fire, using glow statistics, for the case where the flame itself is hidden. Finally the alarm logic applies a threshold and, on video, requires six detections in fifteen frames. In total 39.3 million parameters, 17.7 million of them trained in stage 1.</a:t>
             </a:r>
             <a:endParaRPr lang="en-US" dirty="0"/>
           </a:p>
@@ -2365,6 +2369,182 @@
             <a:fld id="{F7021451-1387-4CA6-816F-3879F97B5CBC}" type="slidenum">
               <a:rPr lang="en-US"/>
               <a:t>12</a:t>
+            </a:fld>
+            <a:endParaRPr lang="en-US"/>
+          </a:p>
+        </p:txBody>
+      </p:sp>
+    </p:spTree>
+    <p:extLst>
+      <p:ext uri="{BB962C8B-B14F-4D97-AF65-F5344CB8AC3E}">
+        <p14:creationId xmlns:p14="http://schemas.microsoft.com/office/powerpoint/2010/main" val="1024086991"/>
+      </p:ext>
+    </p:extLst>
+  </p:cSld>
+  <p:clrMapOvr>
+    <a:masterClrMapping/>
+  </p:clrMapOvr>
+</p:notes>
+</file>
+
+<file path=ppt/notesSlides/notesSlide13.xml><?xml version="1.0" encoding="utf-8"?>
+<p:notes xmlns:a="http://schemas.openxmlformats.org/drawingml/2006/main" xmlns:r="http://schemas.openxmlformats.org/officeDocument/2006/relationships" xmlns:p="http://schemas.openxmlformats.org/presentationml/2006/main">
+  <p:cSld>
+    <p:spTree>
+      <p:nvGrpSpPr>
+        <p:cNvPr id="1" name=""/>
+        <p:cNvGrpSpPr/>
+        <p:nvPr/>
+      </p:nvGrpSpPr>
+      <p:grpSpPr>
+        <a:xfrm>
+          <a:off x="0" y="0"/>
+          <a:ext cx="0" cy="0"/>
+          <a:chOff x="0" y="0"/>
+          <a:chExt cx="0" cy="0"/>
+        </a:xfrm>
+      </p:grpSpPr>
+      <p:sp>
+        <p:nvSpPr>
+          <p:cNvPr id="2" name="Slide Image Placeholder 1"/>
+          <p:cNvSpPr>
+            <a:spLocks noGrp="1" noRot="1" noChangeAspect="1"/>
+          </p:cNvSpPr>
+          <p:nvPr>
+            <p:ph type="sldImg"/>
+          </p:nvPr>
+        </p:nvSpPr>
+        <p:spPr/>
+      </p:sp>
+      <p:sp>
+        <p:nvSpPr>
+          <p:cNvPr id="3" name="Notes Placeholder 2"/>
+          <p:cNvSpPr>
+            <a:spLocks noGrp="1"/>
+          </p:cNvSpPr>
+          <p:nvPr>
+            <p:ph type="body" idx="1"/>
+          </p:nvPr>
+        </p:nvSpPr>
+        <p:spPr/>
+        <p:txBody>
+          <a:bodyPr/>
+          <a:lstStyle/>
+          <a:p>
+            <a:r>
+              <a:rPr lang="en-US" dirty="0"/>
+              <a:t>Six problems met on the way to stage 1. First, data: the site has no recorded fires, so we could not collect fire images there. We used the public D-Fire dataset, which is already annotated with boxes for smoke and fire. Our own work on the data was to check every label file, correct 8 boxes that ran outside the image, filter out 18 zero-area boxes, and create a validation split, keeping the test set untouched. Second, D-Fire is mostly daytime, so we simulate low light and infrared cameras. Third, hidden fire: we cover part of the flame during training and add a scene classifier. Fourth, false alarms: almost half the images have no fire, which lets us measure them. Fifth, compute: freezing the backbone and saving a checkpoint every epoch let us train within free Kaggle sessions. Sixth, DINOv3 outputs one scale, so we built a pyramid.</a:t>
+            </a:r>
+            <a:endParaRPr lang="en-US" dirty="0"/>
+          </a:p>
+        </p:txBody>
+      </p:sp>
+      <p:sp>
+        <p:nvSpPr>
+          <p:cNvPr id="4" name="Slide Number Placeholder 3"/>
+          <p:cNvSpPr>
+            <a:spLocks noGrp="1"/>
+          </p:cNvSpPr>
+          <p:nvPr>
+            <p:ph type="sldNum" sz="quarter" idx="10"/>
+          </p:nvPr>
+        </p:nvSpPr>
+        <p:spPr/>
+        <p:txBody>
+          <a:bodyPr/>
+          <a:lstStyle/>
+          <a:p>
+            <a:fld id="{F7021451-1387-4CA6-816F-3879F97B5CBC}" type="slidenum">
+              <a:rPr lang="en-US"/>
+              <a:t>13</a:t>
+            </a:fld>
+            <a:endParaRPr lang="en-US"/>
+          </a:p>
+        </p:txBody>
+      </p:sp>
+    </p:spTree>
+    <p:extLst>
+      <p:ext uri="{BB962C8B-B14F-4D97-AF65-F5344CB8AC3E}">
+        <p14:creationId xmlns:p14="http://schemas.microsoft.com/office/powerpoint/2010/main" val="1024086991"/>
+      </p:ext>
+    </p:extLst>
+  </p:cSld>
+  <p:clrMapOvr>
+    <a:masterClrMapping/>
+  </p:clrMapOvr>
+</p:notes>
+</file>
+
+<file path=ppt/notesSlides/notesSlide14.xml><?xml version="1.0" encoding="utf-8"?>
+<p:notes xmlns:a="http://schemas.openxmlformats.org/drawingml/2006/main" xmlns:r="http://schemas.openxmlformats.org/officeDocument/2006/relationships" xmlns:p="http://schemas.openxmlformats.org/presentationml/2006/main">
+  <p:cSld>
+    <p:spTree>
+      <p:nvGrpSpPr>
+        <p:cNvPr id="1" name=""/>
+        <p:cNvGrpSpPr/>
+        <p:nvPr/>
+      </p:nvGrpSpPr>
+      <p:grpSpPr>
+        <a:xfrm>
+          <a:off x="0" y="0"/>
+          <a:ext cx="0" cy="0"/>
+          <a:chOff x="0" y="0"/>
+          <a:chExt cx="0" cy="0"/>
+        </a:xfrm>
+      </p:grpSpPr>
+      <p:sp>
+        <p:nvSpPr>
+          <p:cNvPr id="2" name="Slide Image Placeholder 1"/>
+          <p:cNvSpPr>
+            <a:spLocks noGrp="1" noRot="1" noChangeAspect="1"/>
+          </p:cNvSpPr>
+          <p:nvPr>
+            <p:ph type="sldImg"/>
+          </p:nvPr>
+        </p:nvSpPr>
+        <p:spPr/>
+      </p:sp>
+      <p:sp>
+        <p:nvSpPr>
+          <p:cNvPr id="3" name="Notes Placeholder 2"/>
+          <p:cNvSpPr>
+            <a:spLocks noGrp="1"/>
+          </p:cNvSpPr>
+          <p:nvPr>
+            <p:ph type="body" idx="1"/>
+          </p:nvPr>
+        </p:nvSpPr>
+        <p:spPr/>
+        <p:txBody>
+          <a:bodyPr/>
+          <a:lstStyle/>
+          <a:p>
+            <a:r>
+              <a:rPr lang="en-US" dirty="0"/>
+              <a:t>The plan from here. First fine-tune part of the DINOv3 backbone at a low learning rate, which is where overfitting must be watched. Then small and distant fires, hard negatives to push false alarms down, testing on video, a fast version for the 70-camera requirement, and data from the site's own cameras. The full report has the results of every epoch for every model.</a:t>
+            </a:r>
+            <a:endParaRPr lang="en-US" dirty="0"/>
+          </a:p>
+        </p:txBody>
+      </p:sp>
+      <p:sp>
+        <p:nvSpPr>
+          <p:cNvPr id="4" name="Slide Number Placeholder 3"/>
+          <p:cNvSpPr>
+            <a:spLocks noGrp="1"/>
+          </p:cNvSpPr>
+          <p:nvPr>
+            <p:ph type="sldNum" sz="quarter" idx="10"/>
+          </p:nvPr>
+        </p:nvSpPr>
+        <p:spPr/>
+        <p:txBody>
+          <a:bodyPr/>
+          <a:lstStyle/>
+          <a:p>
+            <a:fld id="{F7021451-1387-4CA6-816F-3879F97B5CBC}" type="slidenum">
+              <a:rPr lang="en-US"/>
+              <a:t>14</a:t>
             </a:fld>
             <a:endParaRPr lang="en-US"/>
           </a:p>
@@ -6795,7 +6975,7 @@
                   <a:schemeClr val="tx1"/>
                 </a:solidFill>
               </a:rPr>
-              <a:t>Next goals</a:t>
+              <a:t>Complete structure of the selected model</a:t>
             </a:r>
             <a:endParaRPr lang="en-US" sz="3000" dirty="0"/>
           </a:p>
@@ -6809,12 +6989,1218 @@
         </p:nvSpPr>
         <p:spPr>
           <a:xfrm>
-            <a:off x="548640" y="1325880"/>
-            <a:ext cx="5440680" cy="1024128"/>
+            <a:off x="548640" y="1280160"/>
+            <a:ext cx="5212080" cy="676656"/>
           </a:xfrm>
           <a:prstGeom prst="roundRect">
             <a:avLst>
-              <a:gd name="adj" fmla="val 7143"/>
+              <a:gd name="adj" fmla="val 8108"/>
+            </a:avLst>
+          </a:prstGeom>
+          <a:solidFill>
+            <a:schemeClr val="bg1"/>
+          </a:solidFill>
+          <a:ln w="19050">
+            <a:solidFill>
+              <a:srgbClr val="5B6670"/>
+            </a:solidFill>
+            <a:prstDash val="solid"/>
+          </a:ln>
+        </p:spPr>
+      </p:sp>
+      <p:sp>
+        <p:nvSpPr>
+          <p:cNvPr id="4" name="Text 2"/>
+          <p:cNvSpPr txBox="1"/>
+          <p:nvPr/>
+        </p:nvSpPr>
+        <p:spPr>
+          <a:xfrm>
+            <a:off x="594360" y="1280160"/>
+            <a:ext cx="5120640" cy="676656"/>
+          </a:xfrm>
+          <a:prstGeom prst="rect">
+            <a:avLst/>
+          </a:prstGeom>
+          <a:noFill/>
+          <a:ln/>
+        </p:spPr>
+        <p:txBody>
+          <a:bodyPr wrap="square" lIns="0" tIns="0" rIns="0" bIns="0" rtlCol="0" anchor="ctr"/>
+          <a:lstStyle/>
+          <a:p>
+            <a:pPr algn="ctr" indent="0" marL="0">
+              <a:buNone/>
+            </a:pPr>
+            <a:r>
+              <a:rPr lang="en-US" sz="1400" b="1" dirty="0">
+                <a:solidFill>
+                  <a:schemeClr val="tx1"/>
+                </a:solidFill>
+              </a:rPr>
+              <a:t>Camera frame and pre-processing</a:t>
+            </a:r>
+            <a:endParaRPr lang="en-US" sz="1400" dirty="0"/>
+          </a:p>
+          <a:p>
+            <a:pPr algn="ctr" indent="0" marL="0">
+              <a:buNone/>
+            </a:pPr>
+            <a:r>
+              <a:rPr lang="en-US" sz="1100" dirty="0">
+                <a:solidFill>
+                  <a:schemeClr val="accent6"/>
+                </a:solidFill>
+              </a:rPr>
+              <a:t>resized to 640 x 640, shape kept</a:t>
+            </a:r>
+            <a:endParaRPr lang="en-US" sz="1400" dirty="0"/>
+          </a:p>
+        </p:txBody>
+      </p:sp>
+      <p:sp>
+        <p:nvSpPr>
+          <p:cNvPr id="5" name="Shape 3"/>
+          <p:cNvSpPr/>
+          <p:nvPr/>
+        </p:nvSpPr>
+        <p:spPr>
+          <a:xfrm>
+            <a:off x="6263640" y="1408176"/>
+            <a:ext cx="384048" cy="384048"/>
+          </a:xfrm>
+          <a:prstGeom prst="ellipse">
+            <a:avLst/>
+          </a:prstGeom>
+          <a:solidFill>
+            <a:schemeClr val="accent2"/>
+          </a:solidFill>
+          <a:ln w="12700">
+            <a:solidFill>
+              <a:schemeClr val="accent2"/>
+            </a:solidFill>
+            <a:prstDash val="solid"/>
+          </a:ln>
+        </p:spPr>
+      </p:sp>
+      <p:sp>
+        <p:nvSpPr>
+          <p:cNvPr id="6" name="Text 4"/>
+          <p:cNvSpPr txBox="1"/>
+          <p:nvPr/>
+        </p:nvSpPr>
+        <p:spPr>
+          <a:xfrm>
+            <a:off x="6263640" y="1408176"/>
+            <a:ext cx="384048" cy="384048"/>
+          </a:xfrm>
+          <a:prstGeom prst="rect">
+            <a:avLst/>
+          </a:prstGeom>
+          <a:noFill/>
+          <a:ln/>
+        </p:spPr>
+        <p:txBody>
+          <a:bodyPr wrap="square" lIns="0" tIns="0" rIns="0" bIns="0" rtlCol="0" anchor="ctr"/>
+          <a:lstStyle/>
+          <a:p>
+            <a:pPr algn="ctr" indent="0" marL="0">
+              <a:buNone/>
+            </a:pPr>
+            <a:r>
+              <a:rPr lang="en-US" sz="1500" b="1" dirty="0">
+                <a:solidFill>
+                  <a:schemeClr val="bg1"/>
+                </a:solidFill>
+              </a:rPr>
+              <a:t>1</a:t>
+            </a:r>
+            <a:endParaRPr lang="en-US" sz="1500" dirty="0"/>
+          </a:p>
+        </p:txBody>
+      </p:sp>
+      <p:sp>
+        <p:nvSpPr>
+          <p:cNvPr id="7" name="Text 5"/>
+          <p:cNvSpPr txBox="1"/>
+          <p:nvPr/>
+        </p:nvSpPr>
+        <p:spPr>
+          <a:xfrm>
+            <a:off x="6812280" y="1280160"/>
+            <a:ext cx="4800600" cy="676656"/>
+          </a:xfrm>
+          <a:prstGeom prst="rect">
+            <a:avLst/>
+          </a:prstGeom>
+          <a:noFill/>
+          <a:ln/>
+        </p:spPr>
+        <p:txBody>
+          <a:bodyPr wrap="square" lIns="0" tIns="0" rIns="0" bIns="0" rtlCol="0" anchor="ctr"/>
+          <a:lstStyle/>
+          <a:p>
+            <a:pPr indent="0" marL="0">
+              <a:buNone/>
+            </a:pPr>
+            <a:r>
+              <a:rPr lang="en-US" sz="1300" b="1" dirty="0">
+                <a:solidFill>
+                  <a:schemeClr val="tx1"/>
+                </a:solidFill>
+              </a:rPr>
+              <a:t>Camera frame and pre-processing  </a:t>
+            </a:r>
+            <a:pPr indent="0" marL="0">
+              <a:buNone/>
+            </a:pPr>
+            <a:r>
+              <a:rPr lang="en-US" sz="1300" dirty="0">
+                <a:solidFill>
+                  <a:schemeClr val="tx1"/>
+                </a:solidFill>
+              </a:rPr>
+              <a:t>The camera frame is resized to 640 x 640 with its shape kept, then normalised.</a:t>
+            </a:r>
+            <a:endParaRPr lang="en-US" sz="1300" dirty="0"/>
+          </a:p>
+        </p:txBody>
+      </p:sp>
+      <p:sp>
+        <p:nvSpPr>
+          <p:cNvPr id="8" name="Shape 6"/>
+          <p:cNvSpPr/>
+          <p:nvPr/>
+        </p:nvSpPr>
+        <p:spPr>
+          <a:xfrm>
+            <a:off x="3154680" y="1984248"/>
+            <a:ext cx="0" cy="219456"/>
+          </a:xfrm>
+          <a:prstGeom prst="line">
+            <a:avLst/>
+          </a:prstGeom>
+          <a:noFill/>
+          <a:ln w="19050">
+            <a:solidFill>
+              <a:srgbClr val="5B6670"/>
+            </a:solidFill>
+            <a:prstDash val="solid"/>
+            <a:tailEnd type="triangle"/>
+          </a:ln>
+        </p:spPr>
+      </p:sp>
+      <p:sp>
+        <p:nvSpPr>
+          <p:cNvPr id="9" name="Shape 7"/>
+          <p:cNvSpPr/>
+          <p:nvPr/>
+        </p:nvSpPr>
+        <p:spPr>
+          <a:xfrm>
+            <a:off x="548640" y="2231136"/>
+            <a:ext cx="5212080" cy="676656"/>
+          </a:xfrm>
+          <a:prstGeom prst="roundRect">
+            <a:avLst>
+              <a:gd name="adj" fmla="val 8108"/>
+            </a:avLst>
+          </a:prstGeom>
+          <a:solidFill>
+            <a:schemeClr val="bg2"/>
+          </a:solidFill>
+          <a:ln w="19050">
+            <a:solidFill>
+              <a:srgbClr val="1F6F8B"/>
+            </a:solidFill>
+            <a:prstDash val="solid"/>
+          </a:ln>
+        </p:spPr>
+      </p:sp>
+      <p:sp>
+        <p:nvSpPr>
+          <p:cNvPr id="10" name="Text 8"/>
+          <p:cNvSpPr txBox="1"/>
+          <p:nvPr/>
+        </p:nvSpPr>
+        <p:spPr>
+          <a:xfrm>
+            <a:off x="594360" y="2231136"/>
+            <a:ext cx="5120640" cy="676656"/>
+          </a:xfrm>
+          <a:prstGeom prst="rect">
+            <a:avLst/>
+          </a:prstGeom>
+          <a:noFill/>
+          <a:ln/>
+        </p:spPr>
+        <p:txBody>
+          <a:bodyPr wrap="square" lIns="0" tIns="0" rIns="0" bIns="0" rtlCol="0" anchor="ctr"/>
+          <a:lstStyle/>
+          <a:p>
+            <a:pPr algn="ctr" indent="0" marL="0">
+              <a:buNone/>
+            </a:pPr>
+            <a:r>
+              <a:rPr lang="en-US" sz="1400" b="1" dirty="0">
+                <a:solidFill>
+                  <a:schemeClr val="tx1"/>
+                </a:solidFill>
+              </a:rPr>
+              <a:t>Backbone: DINOv3 ViT-S/16</a:t>
+            </a:r>
+            <a:endParaRPr lang="en-US" sz="1400" dirty="0"/>
+          </a:p>
+          <a:p>
+            <a:pPr algn="ctr" indent="0" marL="0">
+              <a:buNone/>
+            </a:pPr>
+            <a:r>
+              <a:rPr lang="en-US" sz="1100" dirty="0">
+                <a:solidFill>
+                  <a:schemeClr val="accent6"/>
+                </a:solidFill>
+              </a:rPr>
+              <a:t>12 transformer blocks  |  21.6M parameters, frozen</a:t>
+            </a:r>
+            <a:endParaRPr lang="en-US" sz="1400" dirty="0"/>
+          </a:p>
+        </p:txBody>
+      </p:sp>
+      <p:sp>
+        <p:nvSpPr>
+          <p:cNvPr id="11" name="Shape 9"/>
+          <p:cNvSpPr/>
+          <p:nvPr/>
+        </p:nvSpPr>
+        <p:spPr>
+          <a:xfrm>
+            <a:off x="6263640" y="2359152"/>
+            <a:ext cx="384048" cy="384048"/>
+          </a:xfrm>
+          <a:prstGeom prst="ellipse">
+            <a:avLst/>
+          </a:prstGeom>
+          <a:solidFill>
+            <a:schemeClr val="accent2"/>
+          </a:solidFill>
+          <a:ln w="12700">
+            <a:solidFill>
+              <a:schemeClr val="accent2"/>
+            </a:solidFill>
+            <a:prstDash val="solid"/>
+          </a:ln>
+        </p:spPr>
+      </p:sp>
+      <p:sp>
+        <p:nvSpPr>
+          <p:cNvPr id="12" name="Text 10"/>
+          <p:cNvSpPr txBox="1"/>
+          <p:nvPr/>
+        </p:nvSpPr>
+        <p:spPr>
+          <a:xfrm>
+            <a:off x="6263640" y="2359152"/>
+            <a:ext cx="384048" cy="384048"/>
+          </a:xfrm>
+          <a:prstGeom prst="rect">
+            <a:avLst/>
+          </a:prstGeom>
+          <a:noFill/>
+          <a:ln/>
+        </p:spPr>
+        <p:txBody>
+          <a:bodyPr wrap="square" lIns="0" tIns="0" rIns="0" bIns="0" rtlCol="0" anchor="ctr"/>
+          <a:lstStyle/>
+          <a:p>
+            <a:pPr algn="ctr" indent="0" marL="0">
+              <a:buNone/>
+            </a:pPr>
+            <a:r>
+              <a:rPr lang="en-US" sz="1500" b="1" dirty="0">
+                <a:solidFill>
+                  <a:schemeClr val="bg1"/>
+                </a:solidFill>
+              </a:rPr>
+              <a:t>2</a:t>
+            </a:r>
+            <a:endParaRPr lang="en-US" sz="1500" dirty="0"/>
+          </a:p>
+        </p:txBody>
+      </p:sp>
+      <p:sp>
+        <p:nvSpPr>
+          <p:cNvPr id="13" name="Text 11"/>
+          <p:cNvSpPr txBox="1"/>
+          <p:nvPr/>
+        </p:nvSpPr>
+        <p:spPr>
+          <a:xfrm>
+            <a:off x="6812280" y="2231136"/>
+            <a:ext cx="4800600" cy="676656"/>
+          </a:xfrm>
+          <a:prstGeom prst="rect">
+            <a:avLst/>
+          </a:prstGeom>
+          <a:noFill/>
+          <a:ln/>
+        </p:spPr>
+        <p:txBody>
+          <a:bodyPr wrap="square" lIns="0" tIns="0" rIns="0" bIns="0" rtlCol="0" anchor="ctr"/>
+          <a:lstStyle/>
+          <a:p>
+            <a:pPr indent="0" marL="0">
+              <a:buNone/>
+            </a:pPr>
+            <a:r>
+              <a:rPr lang="en-US" sz="1300" b="1" dirty="0">
+                <a:solidFill>
+                  <a:schemeClr val="tx1"/>
+                </a:solidFill>
+              </a:rPr>
+              <a:t>Backbone  </a:t>
+            </a:r>
+            <a:pPr indent="0" marL="0">
+              <a:buNone/>
+            </a:pPr>
+            <a:r>
+              <a:rPr lang="en-US" sz="1300" dirty="0">
+                <a:solidFill>
+                  <a:schemeClr val="tx1"/>
+                </a:solidFill>
+              </a:rPr>
+              <a:t>The image becomes 1,600 patch tokens that pass through 12 transformer blocks. Pretrained on 1.689 billion images.</a:t>
+            </a:r>
+            <a:endParaRPr lang="en-US" sz="1300" dirty="0"/>
+          </a:p>
+        </p:txBody>
+      </p:sp>
+      <p:sp>
+        <p:nvSpPr>
+          <p:cNvPr id="14" name="Shape 12"/>
+          <p:cNvSpPr/>
+          <p:nvPr/>
+        </p:nvSpPr>
+        <p:spPr>
+          <a:xfrm>
+            <a:off x="3154680" y="2935224"/>
+            <a:ext cx="0" cy="219456"/>
+          </a:xfrm>
+          <a:prstGeom prst="line">
+            <a:avLst/>
+          </a:prstGeom>
+          <a:noFill/>
+          <a:ln w="19050">
+            <a:solidFill>
+              <a:srgbClr val="5B6670"/>
+            </a:solidFill>
+            <a:prstDash val="solid"/>
+            <a:tailEnd type="triangle"/>
+          </a:ln>
+        </p:spPr>
+      </p:sp>
+      <p:sp>
+        <p:nvSpPr>
+          <p:cNvPr id="15" name="Shape 13"/>
+          <p:cNvSpPr/>
+          <p:nvPr/>
+        </p:nvSpPr>
+        <p:spPr>
+          <a:xfrm>
+            <a:off x="548640" y="3182112"/>
+            <a:ext cx="5212080" cy="676656"/>
+          </a:xfrm>
+          <a:prstGeom prst="roundRect">
+            <a:avLst>
+              <a:gd name="adj" fmla="val 8108"/>
+            </a:avLst>
+          </a:prstGeom>
+          <a:solidFill>
+            <a:schemeClr val="bg2"/>
+          </a:solidFill>
+          <a:ln w="19050">
+            <a:solidFill>
+              <a:srgbClr val="1F6F8B"/>
+            </a:solidFill>
+            <a:prstDash val="solid"/>
+          </a:ln>
+        </p:spPr>
+      </p:sp>
+      <p:sp>
+        <p:nvSpPr>
+          <p:cNvPr id="16" name="Text 14"/>
+          <p:cNvSpPr txBox="1"/>
+          <p:nvPr/>
+        </p:nvSpPr>
+        <p:spPr>
+          <a:xfrm>
+            <a:off x="594360" y="3182112"/>
+            <a:ext cx="5120640" cy="676656"/>
+          </a:xfrm>
+          <a:prstGeom prst="rect">
+            <a:avLst/>
+          </a:prstGeom>
+          <a:noFill/>
+          <a:ln/>
+        </p:spPr>
+        <p:txBody>
+          <a:bodyPr wrap="square" lIns="0" tIns="0" rIns="0" bIns="0" rtlCol="0" anchor="ctr"/>
+          <a:lstStyle/>
+          <a:p>
+            <a:pPr algn="ctr" indent="0" marL="0">
+              <a:buNone/>
+            </a:pPr>
+            <a:r>
+              <a:rPr lang="en-US" sz="1400" b="1" dirty="0">
+                <a:solidFill>
+                  <a:schemeClr val="tx1"/>
+                </a:solidFill>
+              </a:rPr>
+              <a:t>Feature pyramid</a:t>
+            </a:r>
+            <a:endParaRPr lang="en-US" sz="1400" dirty="0"/>
+          </a:p>
+          <a:p>
+            <a:pPr algn="ctr" indent="0" marL="0">
+              <a:buNone/>
+            </a:pPr>
+            <a:r>
+              <a:rPr lang="en-US" sz="1100" dirty="0">
+                <a:solidFill>
+                  <a:schemeClr val="accent6"/>
+                </a:solidFill>
+              </a:rPr>
+              <a:t>4 levels, 256 channels  |  3.02M, trained</a:t>
+            </a:r>
+            <a:endParaRPr lang="en-US" sz="1400" dirty="0"/>
+          </a:p>
+        </p:txBody>
+      </p:sp>
+      <p:sp>
+        <p:nvSpPr>
+          <p:cNvPr id="17" name="Shape 15"/>
+          <p:cNvSpPr/>
+          <p:nvPr/>
+        </p:nvSpPr>
+        <p:spPr>
+          <a:xfrm>
+            <a:off x="6263640" y="3310128"/>
+            <a:ext cx="384048" cy="384048"/>
+          </a:xfrm>
+          <a:prstGeom prst="ellipse">
+            <a:avLst/>
+          </a:prstGeom>
+          <a:solidFill>
+            <a:schemeClr val="accent2"/>
+          </a:solidFill>
+          <a:ln w="12700">
+            <a:solidFill>
+              <a:schemeClr val="accent2"/>
+            </a:solidFill>
+            <a:prstDash val="solid"/>
+          </a:ln>
+        </p:spPr>
+      </p:sp>
+      <p:sp>
+        <p:nvSpPr>
+          <p:cNvPr id="18" name="Text 16"/>
+          <p:cNvSpPr txBox="1"/>
+          <p:nvPr/>
+        </p:nvSpPr>
+        <p:spPr>
+          <a:xfrm>
+            <a:off x="6263640" y="3310128"/>
+            <a:ext cx="384048" cy="384048"/>
+          </a:xfrm>
+          <a:prstGeom prst="rect">
+            <a:avLst/>
+          </a:prstGeom>
+          <a:noFill/>
+          <a:ln/>
+        </p:spPr>
+        <p:txBody>
+          <a:bodyPr wrap="square" lIns="0" tIns="0" rIns="0" bIns="0" rtlCol="0" anchor="ctr"/>
+          <a:lstStyle/>
+          <a:p>
+            <a:pPr algn="ctr" indent="0" marL="0">
+              <a:buNone/>
+            </a:pPr>
+            <a:r>
+              <a:rPr lang="en-US" sz="1500" b="1" dirty="0">
+                <a:solidFill>
+                  <a:schemeClr val="bg1"/>
+                </a:solidFill>
+              </a:rPr>
+              <a:t>3</a:t>
+            </a:r>
+            <a:endParaRPr lang="en-US" sz="1500" dirty="0"/>
+          </a:p>
+        </p:txBody>
+      </p:sp>
+      <p:sp>
+        <p:nvSpPr>
+          <p:cNvPr id="19" name="Text 17"/>
+          <p:cNvSpPr txBox="1"/>
+          <p:nvPr/>
+        </p:nvSpPr>
+        <p:spPr>
+          <a:xfrm>
+            <a:off x="6812280" y="3182112"/>
+            <a:ext cx="4800600" cy="676656"/>
+          </a:xfrm>
+          <a:prstGeom prst="rect">
+            <a:avLst/>
+          </a:prstGeom>
+          <a:noFill/>
+          <a:ln/>
+        </p:spPr>
+        <p:txBody>
+          <a:bodyPr wrap="square" lIns="0" tIns="0" rIns="0" bIns="0" rtlCol="0" anchor="ctr"/>
+          <a:lstStyle/>
+          <a:p>
+            <a:pPr indent="0" marL="0">
+              <a:buNone/>
+            </a:pPr>
+            <a:r>
+              <a:rPr lang="en-US" sz="1300" b="1" dirty="0">
+                <a:solidFill>
+                  <a:schemeClr val="tx1"/>
+                </a:solidFill>
+              </a:rPr>
+              <a:t>Feature pyramid  </a:t>
+            </a:r>
+            <a:pPr indent="0" marL="0">
+              <a:buNone/>
+            </a:pPr>
+            <a:r>
+              <a:rPr lang="en-US" sz="1300" dirty="0">
+                <a:solidFill>
+                  <a:schemeClr val="tx1"/>
+                </a:solidFill>
+              </a:rPr>
+              <a:t>Four feature maps (80, 40, 20 and 10 cells wide), so that both large and small fires are covered.</a:t>
+            </a:r>
+            <a:endParaRPr lang="en-US" sz="1300" dirty="0"/>
+          </a:p>
+        </p:txBody>
+      </p:sp>
+      <p:sp>
+        <p:nvSpPr>
+          <p:cNvPr id="20" name="Shape 18"/>
+          <p:cNvSpPr/>
+          <p:nvPr/>
+        </p:nvSpPr>
+        <p:spPr>
+          <a:xfrm>
+            <a:off x="3154680" y="3886200"/>
+            <a:ext cx="0" cy="219456"/>
+          </a:xfrm>
+          <a:prstGeom prst="line">
+            <a:avLst/>
+          </a:prstGeom>
+          <a:noFill/>
+          <a:ln w="19050">
+            <a:solidFill>
+              <a:srgbClr val="5B6670"/>
+            </a:solidFill>
+            <a:prstDash val="solid"/>
+            <a:tailEnd type="triangle"/>
+          </a:ln>
+        </p:spPr>
+      </p:sp>
+      <p:sp>
+        <p:nvSpPr>
+          <p:cNvPr id="21" name="Shape 19"/>
+          <p:cNvSpPr/>
+          <p:nvPr/>
+        </p:nvSpPr>
+        <p:spPr>
+          <a:xfrm>
+            <a:off x="548640" y="4133088"/>
+            <a:ext cx="2491740" cy="676656"/>
+          </a:xfrm>
+          <a:prstGeom prst="roundRect">
+            <a:avLst>
+              <a:gd name="adj" fmla="val 8108"/>
+            </a:avLst>
+          </a:prstGeom>
+          <a:solidFill>
+            <a:schemeClr val="bg2"/>
+          </a:solidFill>
+          <a:ln w="19050">
+            <a:solidFill>
+              <a:srgbClr val="E4572E"/>
+            </a:solidFill>
+            <a:prstDash val="solid"/>
+          </a:ln>
+        </p:spPr>
+      </p:sp>
+      <p:sp>
+        <p:nvSpPr>
+          <p:cNvPr id="22" name="Text 20"/>
+          <p:cNvSpPr txBox="1"/>
+          <p:nvPr/>
+        </p:nvSpPr>
+        <p:spPr>
+          <a:xfrm>
+            <a:off x="594360" y="4133088"/>
+            <a:ext cx="2400300" cy="676656"/>
+          </a:xfrm>
+          <a:prstGeom prst="rect">
+            <a:avLst/>
+          </a:prstGeom>
+          <a:noFill/>
+          <a:ln/>
+        </p:spPr>
+        <p:txBody>
+          <a:bodyPr wrap="square" lIns="0" tIns="0" rIns="0" bIns="0" rtlCol="0" anchor="ctr"/>
+          <a:lstStyle/>
+          <a:p>
+            <a:pPr algn="ctr" indent="0" marL="0">
+              <a:buNone/>
+            </a:pPr>
+            <a:r>
+              <a:rPr lang="en-US" sz="1200" b="1" dirty="0">
+                <a:solidFill>
+                  <a:schemeClr val="tx1"/>
+                </a:solidFill>
+              </a:rPr>
+              <a:t>Detection head: Faster R-CNN</a:t>
+            </a:r>
+            <a:endParaRPr lang="en-US" sz="1200" dirty="0"/>
+          </a:p>
+          <a:p>
+            <a:pPr algn="ctr" indent="0" marL="0">
+              <a:buNone/>
+            </a:pPr>
+            <a:r>
+              <a:rPr lang="en-US" sz="1000" dirty="0">
+                <a:solidFill>
+                  <a:schemeClr val="accent6"/>
+                </a:solidFill>
+              </a:rPr>
+              <a:t>boxes, class, score  |  14.5M, trained</a:t>
+            </a:r>
+            <a:endParaRPr lang="en-US" sz="1200" dirty="0"/>
+          </a:p>
+        </p:txBody>
+      </p:sp>
+      <p:sp>
+        <p:nvSpPr>
+          <p:cNvPr id="23" name="Shape 21"/>
+          <p:cNvSpPr/>
+          <p:nvPr/>
+        </p:nvSpPr>
+        <p:spPr>
+          <a:xfrm>
+            <a:off x="3268980" y="4133088"/>
+            <a:ext cx="2491740" cy="676656"/>
+          </a:xfrm>
+          <a:prstGeom prst="roundRect">
+            <a:avLst>
+              <a:gd name="adj" fmla="val 8108"/>
+            </a:avLst>
+          </a:prstGeom>
+          <a:solidFill>
+            <a:schemeClr val="bg2"/>
+          </a:solidFill>
+          <a:ln w="19050">
+            <a:solidFill>
+              <a:srgbClr val="6A1B9A"/>
+            </a:solidFill>
+            <a:prstDash val="solid"/>
+          </a:ln>
+        </p:spPr>
+      </p:sp>
+      <p:sp>
+        <p:nvSpPr>
+          <p:cNvPr id="24" name="Text 22"/>
+          <p:cNvSpPr txBox="1"/>
+          <p:nvPr/>
+        </p:nvSpPr>
+        <p:spPr>
+          <a:xfrm>
+            <a:off x="3314700" y="4133088"/>
+            <a:ext cx="2400300" cy="676656"/>
+          </a:xfrm>
+          <a:prstGeom prst="rect">
+            <a:avLst/>
+          </a:prstGeom>
+          <a:noFill/>
+          <a:ln/>
+        </p:spPr>
+        <p:txBody>
+          <a:bodyPr wrap="square" lIns="0" tIns="0" rIns="0" bIns="0" rtlCol="0" anchor="ctr"/>
+          <a:lstStyle/>
+          <a:p>
+            <a:pPr algn="ctr" indent="0" marL="0">
+              <a:buNone/>
+            </a:pPr>
+            <a:r>
+              <a:rPr lang="en-US" sz="1200" b="1" dirty="0">
+                <a:solidFill>
+                  <a:schemeClr val="tx1"/>
+                </a:solidFill>
+              </a:rPr>
+              <a:t>Scene classifier</a:t>
+            </a:r>
+            <a:endParaRPr lang="en-US" sz="1200" dirty="0"/>
+          </a:p>
+          <a:p>
+            <a:pPr algn="ctr" indent="0" marL="0">
+              <a:buNone/>
+            </a:pPr>
+            <a:r>
+              <a:rPr lang="en-US" sz="1000" dirty="0">
+                <a:solidFill>
+                  <a:schemeClr val="accent6"/>
+                </a:solidFill>
+              </a:rPr>
+              <a:t>P(smoke), P(fire)  |  0.20M, trained</a:t>
+            </a:r>
+            <a:endParaRPr lang="en-US" sz="1200" dirty="0"/>
+          </a:p>
+        </p:txBody>
+      </p:sp>
+      <p:sp>
+        <p:nvSpPr>
+          <p:cNvPr id="25" name="Shape 23"/>
+          <p:cNvSpPr/>
+          <p:nvPr/>
+        </p:nvSpPr>
+        <p:spPr>
+          <a:xfrm>
+            <a:off x="6263640" y="4114800"/>
+            <a:ext cx="310896" cy="310896"/>
+          </a:xfrm>
+          <a:prstGeom prst="ellipse">
+            <a:avLst/>
+          </a:prstGeom>
+          <a:solidFill>
+            <a:schemeClr val="accent1"/>
+          </a:solidFill>
+          <a:ln w="12700">
+            <a:solidFill>
+              <a:schemeClr val="accent1"/>
+            </a:solidFill>
+            <a:prstDash val="solid"/>
+          </a:ln>
+        </p:spPr>
+      </p:sp>
+      <p:sp>
+        <p:nvSpPr>
+          <p:cNvPr id="26" name="Text 24"/>
+          <p:cNvSpPr txBox="1"/>
+          <p:nvPr/>
+        </p:nvSpPr>
+        <p:spPr>
+          <a:xfrm>
+            <a:off x="6263640" y="4114800"/>
+            <a:ext cx="310896" cy="310896"/>
+          </a:xfrm>
+          <a:prstGeom prst="rect">
+            <a:avLst/>
+          </a:prstGeom>
+          <a:noFill/>
+          <a:ln/>
+        </p:spPr>
+        <p:txBody>
+          <a:bodyPr wrap="square" lIns="0" tIns="0" rIns="0" bIns="0" rtlCol="0" anchor="ctr"/>
+          <a:lstStyle/>
+          <a:p>
+            <a:pPr algn="ctr" indent="0" marL="0">
+              <a:buNone/>
+            </a:pPr>
+            <a:r>
+              <a:rPr lang="en-US" sz="1500" b="1" dirty="0">
+                <a:solidFill>
+                  <a:schemeClr val="bg1"/>
+                </a:solidFill>
+              </a:rPr>
+              <a:t>4</a:t>
+            </a:r>
+            <a:endParaRPr lang="en-US" sz="1500" dirty="0"/>
+          </a:p>
+        </p:txBody>
+      </p:sp>
+      <p:sp>
+        <p:nvSpPr>
+          <p:cNvPr id="27" name="Text 25"/>
+          <p:cNvSpPr txBox="1"/>
+          <p:nvPr/>
+        </p:nvSpPr>
+        <p:spPr>
+          <a:xfrm>
+            <a:off x="6720840" y="4023360"/>
+            <a:ext cx="4892040" cy="457200"/>
+          </a:xfrm>
+          <a:prstGeom prst="rect">
+            <a:avLst/>
+          </a:prstGeom>
+          <a:noFill/>
+          <a:ln/>
+        </p:spPr>
+        <p:txBody>
+          <a:bodyPr wrap="square" lIns="0" tIns="0" rIns="0" bIns="0" rtlCol="0" anchor="ctr"/>
+          <a:lstStyle/>
+          <a:p>
+            <a:pPr indent="0" marL="0">
+              <a:buNone/>
+            </a:pPr>
+            <a:r>
+              <a:rPr lang="en-US" sz="1200" b="1" dirty="0">
+                <a:solidFill>
+                  <a:schemeClr val="tx1"/>
+                </a:solidFill>
+              </a:rPr>
+              <a:t>Detection head  </a:t>
+            </a:r>
+            <a:pPr indent="0" marL="0">
+              <a:buNone/>
+            </a:pPr>
+            <a:r>
+              <a:rPr lang="en-US" sz="1200" dirty="0">
+                <a:solidFill>
+                  <a:schemeClr val="tx1"/>
+                </a:solidFill>
+              </a:rPr>
+              <a:t>Proposes about 300 regions, then classifies each as smoke or fire and refines its box.</a:t>
+            </a:r>
+            <a:endParaRPr lang="en-US" sz="1200" dirty="0"/>
+          </a:p>
+        </p:txBody>
+      </p:sp>
+      <p:sp>
+        <p:nvSpPr>
+          <p:cNvPr id="28" name="Shape 26"/>
+          <p:cNvSpPr/>
+          <p:nvPr/>
+        </p:nvSpPr>
+        <p:spPr>
+          <a:xfrm>
+            <a:off x="6263640" y="4535424"/>
+            <a:ext cx="310896" cy="310896"/>
+          </a:xfrm>
+          <a:prstGeom prst="ellipse">
+            <a:avLst/>
+          </a:prstGeom>
+          <a:solidFill>
+            <a:schemeClr val="accent1"/>
+          </a:solidFill>
+          <a:ln w="12700">
+            <a:solidFill>
+              <a:schemeClr val="accent1"/>
+            </a:solidFill>
+            <a:prstDash val="solid"/>
+          </a:ln>
+        </p:spPr>
+      </p:sp>
+      <p:sp>
+        <p:nvSpPr>
+          <p:cNvPr id="29" name="Text 27"/>
+          <p:cNvSpPr txBox="1"/>
+          <p:nvPr/>
+        </p:nvSpPr>
+        <p:spPr>
+          <a:xfrm>
+            <a:off x="6263640" y="4535424"/>
+            <a:ext cx="310896" cy="310896"/>
+          </a:xfrm>
+          <a:prstGeom prst="rect">
+            <a:avLst/>
+          </a:prstGeom>
+          <a:noFill/>
+          <a:ln/>
+        </p:spPr>
+        <p:txBody>
+          <a:bodyPr wrap="square" lIns="0" tIns="0" rIns="0" bIns="0" rtlCol="0" anchor="ctr"/>
+          <a:lstStyle/>
+          <a:p>
+            <a:pPr algn="ctr" indent="0" marL="0">
+              <a:buNone/>
+            </a:pPr>
+            <a:r>
+              <a:rPr lang="en-US" sz="1500" b="1" dirty="0">
+                <a:solidFill>
+                  <a:schemeClr val="bg1"/>
+                </a:solidFill>
+              </a:rPr>
+              <a:t>5</a:t>
+            </a:r>
+            <a:endParaRPr lang="en-US" sz="1500" dirty="0"/>
+          </a:p>
+        </p:txBody>
+      </p:sp>
+      <p:sp>
+        <p:nvSpPr>
+          <p:cNvPr id="30" name="Text 28"/>
+          <p:cNvSpPr txBox="1"/>
+          <p:nvPr/>
+        </p:nvSpPr>
+        <p:spPr>
+          <a:xfrm>
+            <a:off x="6720840" y="4462272"/>
+            <a:ext cx="4892040" cy="457200"/>
+          </a:xfrm>
+          <a:prstGeom prst="rect">
+            <a:avLst/>
+          </a:prstGeom>
+          <a:noFill/>
+          <a:ln/>
+        </p:spPr>
+        <p:txBody>
+          <a:bodyPr wrap="square" lIns="0" tIns="0" rIns="0" bIns="0" rtlCol="0" anchor="ctr"/>
+          <a:lstStyle/>
+          <a:p>
+            <a:pPr indent="0" marL="0">
+              <a:buNone/>
+            </a:pPr>
+            <a:r>
+              <a:rPr lang="en-US" sz="1200" b="1" dirty="0">
+                <a:solidFill>
+                  <a:schemeClr val="tx1"/>
+                </a:solidFill>
+              </a:rPr>
+              <a:t>Scene classifier  </a:t>
+            </a:r>
+            <a:pPr indent="0" marL="0">
+              <a:buNone/>
+            </a:pPr>
+            <a:r>
+              <a:rPr lang="en-US" sz="1200" dirty="0">
+                <a:solidFill>
+                  <a:schemeClr val="tx1"/>
+                </a:solidFill>
+              </a:rPr>
+              <a:t>Whole-image check using 7 glow statistics, for fire hidden behind objects.</a:t>
+            </a:r>
+            <a:endParaRPr lang="en-US" sz="1200" dirty="0"/>
+          </a:p>
+        </p:txBody>
+      </p:sp>
+      <p:sp>
+        <p:nvSpPr>
+          <p:cNvPr id="31" name="Shape 29"/>
+          <p:cNvSpPr/>
+          <p:nvPr/>
+        </p:nvSpPr>
+        <p:spPr>
+          <a:xfrm>
+            <a:off x="3154680" y="4837176"/>
+            <a:ext cx="0" cy="219456"/>
+          </a:xfrm>
+          <a:prstGeom prst="line">
+            <a:avLst/>
+          </a:prstGeom>
+          <a:noFill/>
+          <a:ln w="19050">
+            <a:solidFill>
+              <a:srgbClr val="5B6670"/>
+            </a:solidFill>
+            <a:prstDash val="solid"/>
+            <a:tailEnd type="triangle"/>
+          </a:ln>
+        </p:spPr>
+      </p:sp>
+      <p:sp>
+        <p:nvSpPr>
+          <p:cNvPr id="32" name="Shape 30"/>
+          <p:cNvSpPr/>
+          <p:nvPr/>
+        </p:nvSpPr>
+        <p:spPr>
+          <a:xfrm>
+            <a:off x="548640" y="5084064"/>
+            <a:ext cx="5212080" cy="676656"/>
+          </a:xfrm>
+          <a:prstGeom prst="roundRect">
+            <a:avLst>
+              <a:gd name="adj" fmla="val 8108"/>
+            </a:avLst>
+          </a:prstGeom>
+          <a:solidFill>
+            <a:schemeClr val="bg1"/>
+          </a:solidFill>
+          <a:ln w="19050">
+            <a:solidFill>
+              <a:srgbClr val="5B6670"/>
+            </a:solidFill>
+            <a:prstDash val="solid"/>
+          </a:ln>
+        </p:spPr>
+      </p:sp>
+      <p:sp>
+        <p:nvSpPr>
+          <p:cNvPr id="33" name="Text 31"/>
+          <p:cNvSpPr txBox="1"/>
+          <p:nvPr/>
+        </p:nvSpPr>
+        <p:spPr>
+          <a:xfrm>
+            <a:off x="594360" y="5084064"/>
+            <a:ext cx="5120640" cy="676656"/>
+          </a:xfrm>
+          <a:prstGeom prst="rect">
+            <a:avLst/>
+          </a:prstGeom>
+          <a:noFill/>
+          <a:ln/>
+        </p:spPr>
+        <p:txBody>
+          <a:bodyPr wrap="square" lIns="0" tIns="0" rIns="0" bIns="0" rtlCol="0" anchor="ctr"/>
+          <a:lstStyle/>
+          <a:p>
+            <a:pPr algn="ctr" indent="0" marL="0">
+              <a:buNone/>
+            </a:pPr>
+            <a:r>
+              <a:rPr lang="en-US" sz="1400" b="1" dirty="0">
+                <a:solidFill>
+                  <a:schemeClr val="tx1"/>
+                </a:solidFill>
+              </a:rPr>
+              <a:t>Alarm logic</a:t>
+            </a:r>
+            <a:endParaRPr lang="en-US" sz="1400" dirty="0"/>
+          </a:p>
+          <a:p>
+            <a:pPr algn="ctr" indent="0" marL="0">
+              <a:buNone/>
+            </a:pPr>
+            <a:r>
+              <a:rPr lang="en-US" sz="1100" dirty="0">
+                <a:solidFill>
+                  <a:schemeClr val="accent6"/>
+                </a:solidFill>
+              </a:rPr>
+              <a:t>threshold  +  6 detections in 15 frames</a:t>
+            </a:r>
+            <a:endParaRPr lang="en-US" sz="1400" dirty="0"/>
+          </a:p>
+        </p:txBody>
+      </p:sp>
+      <p:sp>
+        <p:nvSpPr>
+          <p:cNvPr id="34" name="Shape 32"/>
+          <p:cNvSpPr/>
+          <p:nvPr/>
+        </p:nvSpPr>
+        <p:spPr>
+          <a:xfrm>
+            <a:off x="6263640" y="5212080"/>
+            <a:ext cx="384048" cy="384048"/>
+          </a:xfrm>
+          <a:prstGeom prst="ellipse">
+            <a:avLst/>
+          </a:prstGeom>
+          <a:solidFill>
+            <a:schemeClr val="accent2"/>
+          </a:solidFill>
+          <a:ln w="12700">
+            <a:solidFill>
+              <a:schemeClr val="accent2"/>
+            </a:solidFill>
+            <a:prstDash val="solid"/>
+          </a:ln>
+        </p:spPr>
+      </p:sp>
+      <p:sp>
+        <p:nvSpPr>
+          <p:cNvPr id="35" name="Text 33"/>
+          <p:cNvSpPr txBox="1"/>
+          <p:nvPr/>
+        </p:nvSpPr>
+        <p:spPr>
+          <a:xfrm>
+            <a:off x="6263640" y="5212080"/>
+            <a:ext cx="384048" cy="384048"/>
+          </a:xfrm>
+          <a:prstGeom prst="rect">
+            <a:avLst/>
+          </a:prstGeom>
+          <a:noFill/>
+          <a:ln/>
+        </p:spPr>
+        <p:txBody>
+          <a:bodyPr wrap="square" lIns="0" tIns="0" rIns="0" bIns="0" rtlCol="0" anchor="ctr"/>
+          <a:lstStyle/>
+          <a:p>
+            <a:pPr algn="ctr" indent="0" marL="0">
+              <a:buNone/>
+            </a:pPr>
+            <a:r>
+              <a:rPr lang="en-US" sz="1500" b="1" dirty="0">
+                <a:solidFill>
+                  <a:schemeClr val="bg1"/>
+                </a:solidFill>
+              </a:rPr>
+              <a:t>6</a:t>
+            </a:r>
+            <a:endParaRPr lang="en-US" sz="1500" dirty="0"/>
+          </a:p>
+        </p:txBody>
+      </p:sp>
+      <p:sp>
+        <p:nvSpPr>
+          <p:cNvPr id="36" name="Text 34"/>
+          <p:cNvSpPr txBox="1"/>
+          <p:nvPr/>
+        </p:nvSpPr>
+        <p:spPr>
+          <a:xfrm>
+            <a:off x="6812280" y="5084064"/>
+            <a:ext cx="4800600" cy="676656"/>
+          </a:xfrm>
+          <a:prstGeom prst="rect">
+            <a:avLst/>
+          </a:prstGeom>
+          <a:noFill/>
+          <a:ln/>
+        </p:spPr>
+        <p:txBody>
+          <a:bodyPr wrap="square" lIns="0" tIns="0" rIns="0" bIns="0" rtlCol="0" anchor="ctr"/>
+          <a:lstStyle/>
+          <a:p>
+            <a:pPr indent="0" marL="0">
+              <a:buNone/>
+            </a:pPr>
+            <a:r>
+              <a:rPr lang="en-US" sz="1300" b="1" dirty="0">
+                <a:solidFill>
+                  <a:schemeClr val="tx1"/>
+                </a:solidFill>
+              </a:rPr>
+              <a:t>Alarm logic  </a:t>
+            </a:r>
+            <a:pPr indent="0" marL="0">
+              <a:buNone/>
+            </a:pPr>
+            <a:r>
+              <a:rPr lang="en-US" sz="1300" dirty="0">
+                <a:solidFill>
+                  <a:schemeClr val="tx1"/>
+                </a:solidFill>
+              </a:rPr>
+              <a:t>The threshold is set for at most 1% false alarms. On video, an alarm needs 6 detections within 15 frames.</a:t>
+            </a:r>
+            <a:endParaRPr lang="en-US" sz="1300" dirty="0"/>
+          </a:p>
+        </p:txBody>
+      </p:sp>
+      <p:sp>
+        <p:nvSpPr>
+          <p:cNvPr id="37" name="Shape 35"/>
+          <p:cNvSpPr/>
+          <p:nvPr/>
+        </p:nvSpPr>
+        <p:spPr>
+          <a:xfrm>
+            <a:off x="548640" y="5989320"/>
+            <a:ext cx="11064240" cy="329184"/>
+          </a:xfrm>
+          <a:prstGeom prst="roundRect">
+            <a:avLst>
+              <a:gd name="adj" fmla="val 22222"/>
             </a:avLst>
           </a:prstGeom>
           <a:solidFill>
@@ -6830,6 +8216,1634 @@
       </p:sp>
       <p:sp>
         <p:nvSpPr>
+          <p:cNvPr id="38" name="Text 36"/>
+          <p:cNvSpPr txBox="1"/>
+          <p:nvPr/>
+        </p:nvSpPr>
+        <p:spPr>
+          <a:xfrm>
+            <a:off x="777240" y="5989320"/>
+            <a:ext cx="10607040" cy="329184"/>
+          </a:xfrm>
+          <a:prstGeom prst="rect">
+            <a:avLst/>
+          </a:prstGeom>
+          <a:noFill/>
+          <a:ln/>
+        </p:spPr>
+        <p:txBody>
+          <a:bodyPr wrap="square" lIns="0" tIns="0" rIns="0" bIns="0" rtlCol="0" anchor="ctr"/>
+          <a:lstStyle/>
+          <a:p>
+            <a:pPr indent="0" marL="0">
+              <a:buNone/>
+            </a:pPr>
+            <a:r>
+              <a:rPr lang="en-US" sz="1200" b="1" dirty="0">
+                <a:solidFill>
+                  <a:schemeClr val="accent1"/>
+                </a:solidFill>
+              </a:rPr>
+              <a:t>Whole model:  </a:t>
+            </a:r>
+            <a:pPr indent="0" marL="0">
+              <a:buNone/>
+            </a:pPr>
+            <a:r>
+              <a:rPr lang="en-US" sz="1200" dirty="0">
+                <a:solidFill>
+                  <a:schemeClr val="tx1"/>
+                </a:solidFill>
+              </a:rPr>
+              <a:t>39.3M parameters, of which 17.7M are trained in stage 1 (the backbone is frozen).</a:t>
+            </a:r>
+            <a:endParaRPr lang="en-US" sz="1200" dirty="0"/>
+          </a:p>
+        </p:txBody>
+      </p:sp>
+      <p:sp>
+        <p:nvSpPr>
+          <p:cNvPr id="25" name="Slide Number Placeholder 0"/>
+          <p:cNvSpPr>
+            <a:spLocks noGrp="1"/>
+          </p:cNvSpPr>
+          <p:nvPr>
+            <p:ph type="sldNum" sz="quarter" idx="4294967295"/>
+          </p:nvPr>
+        </p:nvSpPr>
+        <p:spPr>
+          <a:xfrm>
+            <a:off x="11155680" y="6400800"/>
+            <a:ext cx="548640" cy="274320"/>
+          </a:xfrm>
+          <a:prstGeom prst="rect">
+            <a:avLst/>
+          </a:prstGeom>
+          <a:extLst>
+            <a:ext uri="{C572A759-6A51-4108-AA02-DFA0A04FC94B}">
+              <ma14:wrappingTextBoxFlag xmlns:ma14="http://schemas.microsoft.com/office/mac/drawingml/2011/main" val="0"/>
+            </a:ext>
+          </a:extLst>
+        </p:spPr>
+        <p:txBody>
+          <a:bodyPr/>
+          <a:lstStyle>
+            <a:lvl1pPr>
+              <a:defRPr sz="1000">
+                <a:solidFill>
+                  <a:srgbClr val="5B6670"/>
+                </a:solidFill>
+              </a:defRPr>
+            </a:lvl1pPr>
+          </a:lstStyle>
+          <a:p>
+            <a:pPr algn="r"/>
+            <a:fld id="{F7021451-1387-4CA6-816F-3879F97B5CBC}" type="slidenum">
+              <a:rPr b="0" lang="en-US"/>
+              <a:t>12</a:t>
+            </a:fld>
+            <a:endParaRPr lang="en-US"/>
+          </a:p>
+        </p:txBody>
+      </p:sp>
+    </p:spTree>
+  </p:cSld>
+  <p:clrMapOvr>
+    <a:masterClrMapping/>
+  </p:clrMapOvr>
+</p:sld>
+</file>
+
+<file path=ppt/slides/slide13.xml><?xml version="1.0" encoding="utf-8"?>
+<p:sld xmlns:a="http://schemas.openxmlformats.org/drawingml/2006/main" xmlns:r="http://schemas.openxmlformats.org/officeDocument/2006/relationships" xmlns:p="http://schemas.openxmlformats.org/presentationml/2006/main">
+  <p:cSld name="Slide 13">
+    <p:spTree>
+      <p:nvGrpSpPr>
+        <p:cNvPr id="1" name=""/>
+        <p:cNvGrpSpPr/>
+        <p:nvPr/>
+      </p:nvGrpSpPr>
+      <p:grpSpPr>
+        <a:xfrm>
+          <a:off x="0" y="0"/>
+          <a:ext cx="0" cy="0"/>
+          <a:chOff x="0" y="0"/>
+          <a:chExt cx="0" cy="0"/>
+        </a:xfrm>
+      </p:grpSpPr>
+      <p:sp>
+        <p:nvSpPr>
+          <p:cNvPr id="2" name="Text 0"/>
+          <p:cNvSpPr/>
+          <p:nvPr>
+            <p:ph idx="100" type="title" hasCustomPrompt="1"/>
+          </p:nvPr>
+        </p:nvSpPr>
+        <p:spPr>
+          <a:xfrm>
+            <a:off x="548640" y="274320"/>
+            <a:ext cx="11064240" cy="822960"/>
+          </a:xfrm>
+          <a:prstGeom prst="rect">
+            <a:avLst/>
+          </a:prstGeom>
+          <a:noFill/>
+          <a:ln/>
+        </p:spPr>
+        <p:txBody>
+          <a:bodyPr wrap="square" lIns="0" tIns="0" rIns="0" bIns="0" rtlCol="0" anchor="ctr"/>
+          <a:lstStyle/>
+          <a:p>
+            <a:pPr algn="l" indent="0" marL="0">
+              <a:buNone/>
+            </a:pPr>
+            <a:r>
+              <a:rPr lang="en-US" sz="3000" b="1" dirty="0">
+                <a:solidFill>
+                  <a:schemeClr val="tx1"/>
+                </a:solidFill>
+              </a:rPr>
+              <a:t>Problems faced up to stage 1, and how they were solved</a:t>
+            </a:r>
+            <a:endParaRPr lang="en-US" sz="3000" dirty="0"/>
+          </a:p>
+        </p:txBody>
+      </p:sp>
+      <p:sp>
+        <p:nvSpPr>
+          <p:cNvPr id="3" name="Text 1"/>
+          <p:cNvSpPr txBox="1"/>
+          <p:nvPr/>
+        </p:nvSpPr>
+        <p:spPr>
+          <a:xfrm>
+            <a:off x="548640" y="1188720"/>
+            <a:ext cx="3840480" cy="320040"/>
+          </a:xfrm>
+          <a:prstGeom prst="rect">
+            <a:avLst/>
+          </a:prstGeom>
+          <a:noFill/>
+          <a:ln/>
+        </p:spPr>
+        <p:txBody>
+          <a:bodyPr wrap="square" lIns="0" tIns="0" rIns="0" bIns="0" rtlCol="0" anchor="ctr"/>
+          <a:lstStyle/>
+          <a:p>
+            <a:pPr indent="0" marL="0">
+              <a:buNone/>
+            </a:pPr>
+            <a:r>
+              <a:rPr lang="en-US" sz="1400" b="1" dirty="0">
+                <a:solidFill>
+                  <a:schemeClr val="accent4"/>
+                </a:solidFill>
+              </a:rPr>
+              <a:t>Problem</a:t>
+            </a:r>
+            <a:endParaRPr lang="en-US" sz="1400" dirty="0"/>
+          </a:p>
+        </p:txBody>
+      </p:sp>
+      <p:sp>
+        <p:nvSpPr>
+          <p:cNvPr id="4" name="Text 2"/>
+          <p:cNvSpPr txBox="1"/>
+          <p:nvPr/>
+        </p:nvSpPr>
+        <p:spPr>
+          <a:xfrm>
+            <a:off x="4892040" y="1188720"/>
+            <a:ext cx="6720840" cy="320040"/>
+          </a:xfrm>
+          <a:prstGeom prst="rect">
+            <a:avLst/>
+          </a:prstGeom>
+          <a:noFill/>
+          <a:ln/>
+        </p:spPr>
+        <p:txBody>
+          <a:bodyPr wrap="square" lIns="0" tIns="0" rIns="0" bIns="0" rtlCol="0" anchor="ctr"/>
+          <a:lstStyle/>
+          <a:p>
+            <a:pPr indent="0" marL="0">
+              <a:buNone/>
+            </a:pPr>
+            <a:r>
+              <a:rPr lang="en-US" sz="1400" b="1" dirty="0">
+                <a:solidFill>
+                  <a:schemeClr val="accent3"/>
+                </a:solidFill>
+              </a:rPr>
+              <a:t>How it was solved</a:t>
+            </a:r>
+            <a:endParaRPr lang="en-US" sz="1400" dirty="0"/>
+          </a:p>
+        </p:txBody>
+      </p:sp>
+      <p:sp>
+        <p:nvSpPr>
+          <p:cNvPr id="5" name="Shape 3"/>
+          <p:cNvSpPr/>
+          <p:nvPr/>
+        </p:nvSpPr>
+        <p:spPr>
+          <a:xfrm>
+            <a:off x="548640" y="1572768"/>
+            <a:ext cx="3840480" cy="676656"/>
+          </a:xfrm>
+          <a:prstGeom prst="roundRect">
+            <a:avLst>
+              <a:gd name="adj" fmla="val 10811"/>
+            </a:avLst>
+          </a:prstGeom>
+          <a:solidFill>
+            <a:schemeClr val="bg2"/>
+          </a:solidFill>
+          <a:ln w="9525">
+            <a:solidFill>
+              <a:srgbClr val="D5DAE0"/>
+            </a:solidFill>
+            <a:prstDash val="solid"/>
+          </a:ln>
+        </p:spPr>
+      </p:sp>
+      <p:sp>
+        <p:nvSpPr>
+          <p:cNvPr id="6" name="Shape 4"/>
+          <p:cNvSpPr/>
+          <p:nvPr/>
+        </p:nvSpPr>
+        <p:spPr>
+          <a:xfrm>
+            <a:off x="685800" y="1719072"/>
+            <a:ext cx="384048" cy="384048"/>
+          </a:xfrm>
+          <a:prstGeom prst="ellipse">
+            <a:avLst/>
+          </a:prstGeom>
+          <a:solidFill>
+            <a:schemeClr val="accent4"/>
+          </a:solidFill>
+          <a:ln w="12700">
+            <a:solidFill>
+              <a:schemeClr val="accent4"/>
+            </a:solidFill>
+            <a:prstDash val="solid"/>
+          </a:ln>
+        </p:spPr>
+      </p:sp>
+      <p:sp>
+        <p:nvSpPr>
+          <p:cNvPr id="7" name="Text 5"/>
+          <p:cNvSpPr txBox="1"/>
+          <p:nvPr/>
+        </p:nvSpPr>
+        <p:spPr>
+          <a:xfrm>
+            <a:off x="685800" y="1719072"/>
+            <a:ext cx="384048" cy="384048"/>
+          </a:xfrm>
+          <a:prstGeom prst="rect">
+            <a:avLst/>
+          </a:prstGeom>
+          <a:noFill/>
+          <a:ln/>
+        </p:spPr>
+        <p:txBody>
+          <a:bodyPr wrap="square" lIns="0" tIns="0" rIns="0" bIns="0" rtlCol="0" anchor="ctr"/>
+          <a:lstStyle/>
+          <a:p>
+            <a:pPr algn="ctr" indent="0" marL="0">
+              <a:buNone/>
+            </a:pPr>
+            <a:r>
+              <a:rPr lang="en-US" sz="1500" b="1" dirty="0">
+                <a:solidFill>
+                  <a:schemeClr val="bg1"/>
+                </a:solidFill>
+              </a:rPr>
+              <a:t>1</a:t>
+            </a:r>
+            <a:endParaRPr lang="en-US" sz="1500" dirty="0"/>
+          </a:p>
+        </p:txBody>
+      </p:sp>
+      <p:sp>
+        <p:nvSpPr>
+          <p:cNvPr id="8" name="Text 6"/>
+          <p:cNvSpPr txBox="1"/>
+          <p:nvPr/>
+        </p:nvSpPr>
+        <p:spPr>
+          <a:xfrm>
+            <a:off x="1188720" y="1572768"/>
+            <a:ext cx="3108960" cy="676656"/>
+          </a:xfrm>
+          <a:prstGeom prst="rect">
+            <a:avLst/>
+          </a:prstGeom>
+          <a:noFill/>
+          <a:ln/>
+        </p:spPr>
+        <p:txBody>
+          <a:bodyPr wrap="square" lIns="0" tIns="0" rIns="0" bIns="0" rtlCol="0" anchor="ctr"/>
+          <a:lstStyle/>
+          <a:p>
+            <a:pPr indent="0" marL="0">
+              <a:buNone/>
+            </a:pPr>
+            <a:r>
+              <a:rPr lang="en-US" sz="1300" b="1" dirty="0">
+                <a:solidFill>
+                  <a:schemeClr val="tx1"/>
+                </a:solidFill>
+              </a:rPr>
+              <a:t>Data shortage: no fire footage from the site</a:t>
+            </a:r>
+            <a:endParaRPr lang="en-US" sz="1300" dirty="0"/>
+          </a:p>
+        </p:txBody>
+      </p:sp>
+      <p:sp>
+        <p:nvSpPr>
+          <p:cNvPr id="9" name="Shape 7"/>
+          <p:cNvSpPr/>
+          <p:nvPr/>
+        </p:nvSpPr>
+        <p:spPr>
+          <a:xfrm>
+            <a:off x="4443984" y="1911096"/>
+            <a:ext cx="393192" cy="0"/>
+          </a:xfrm>
+          <a:prstGeom prst="line">
+            <a:avLst/>
+          </a:prstGeom>
+          <a:noFill/>
+          <a:ln w="19050">
+            <a:solidFill>
+              <a:srgbClr val="5B6670"/>
+            </a:solidFill>
+            <a:prstDash val="solid"/>
+            <a:tailEnd type="triangle"/>
+          </a:ln>
+        </p:spPr>
+      </p:sp>
+      <p:sp>
+        <p:nvSpPr>
+          <p:cNvPr id="10" name="Shape 8"/>
+          <p:cNvSpPr/>
+          <p:nvPr/>
+        </p:nvSpPr>
+        <p:spPr>
+          <a:xfrm>
+            <a:off x="4892040" y="1572768"/>
+            <a:ext cx="6720840" cy="676656"/>
+          </a:xfrm>
+          <a:prstGeom prst="roundRect">
+            <a:avLst>
+              <a:gd name="adj" fmla="val 10811"/>
+            </a:avLst>
+          </a:prstGeom>
+          <a:solidFill>
+            <a:schemeClr val="bg2"/>
+          </a:solidFill>
+          <a:ln w="9525">
+            <a:solidFill>
+              <a:srgbClr val="D5DAE0"/>
+            </a:solidFill>
+            <a:prstDash val="solid"/>
+          </a:ln>
+        </p:spPr>
+      </p:sp>
+      <p:sp>
+        <p:nvSpPr>
+          <p:cNvPr id="11" name="Text 9"/>
+          <p:cNvSpPr txBox="1"/>
+          <p:nvPr/>
+        </p:nvSpPr>
+        <p:spPr>
+          <a:xfrm>
+            <a:off x="5074920" y="1572768"/>
+            <a:ext cx="6355080" cy="676656"/>
+          </a:xfrm>
+          <a:prstGeom prst="rect">
+            <a:avLst/>
+          </a:prstGeom>
+          <a:noFill/>
+          <a:ln/>
+        </p:spPr>
+        <p:txBody>
+          <a:bodyPr wrap="square" lIns="0" tIns="0" rIns="0" bIns="0" rtlCol="0" anchor="ctr"/>
+          <a:lstStyle/>
+          <a:p>
+            <a:pPr indent="0" marL="0">
+              <a:buNone/>
+            </a:pPr>
+            <a:r>
+              <a:rPr lang="en-US" sz="1300" dirty="0">
+                <a:solidFill>
+                  <a:schemeClr val="tx1"/>
+                </a:solidFill>
+              </a:rPr>
+              <a:t>Used the public D-Fire dataset (21,527 annotated images). Every label was checked, faulty boxes were corrected or filtered, and our own train / validation / test split was made</a:t>
+            </a:r>
+            <a:endParaRPr lang="en-US" sz="1300" dirty="0"/>
+          </a:p>
+        </p:txBody>
+      </p:sp>
+      <p:sp>
+        <p:nvSpPr>
+          <p:cNvPr id="12" name="Shape 10"/>
+          <p:cNvSpPr/>
+          <p:nvPr/>
+        </p:nvSpPr>
+        <p:spPr>
+          <a:xfrm>
+            <a:off x="548640" y="2359152"/>
+            <a:ext cx="3840480" cy="676656"/>
+          </a:xfrm>
+          <a:prstGeom prst="roundRect">
+            <a:avLst>
+              <a:gd name="adj" fmla="val 10811"/>
+            </a:avLst>
+          </a:prstGeom>
+          <a:solidFill>
+            <a:schemeClr val="bg2"/>
+          </a:solidFill>
+          <a:ln w="9525">
+            <a:solidFill>
+              <a:srgbClr val="D5DAE0"/>
+            </a:solidFill>
+            <a:prstDash val="solid"/>
+          </a:ln>
+        </p:spPr>
+      </p:sp>
+      <p:sp>
+        <p:nvSpPr>
+          <p:cNvPr id="13" name="Shape 11"/>
+          <p:cNvSpPr/>
+          <p:nvPr/>
+        </p:nvSpPr>
+        <p:spPr>
+          <a:xfrm>
+            <a:off x="685800" y="2505456"/>
+            <a:ext cx="384048" cy="384048"/>
+          </a:xfrm>
+          <a:prstGeom prst="ellipse">
+            <a:avLst/>
+          </a:prstGeom>
+          <a:solidFill>
+            <a:schemeClr val="accent4"/>
+          </a:solidFill>
+          <a:ln w="12700">
+            <a:solidFill>
+              <a:schemeClr val="accent4"/>
+            </a:solidFill>
+            <a:prstDash val="solid"/>
+          </a:ln>
+        </p:spPr>
+      </p:sp>
+      <p:sp>
+        <p:nvSpPr>
+          <p:cNvPr id="14" name="Text 12"/>
+          <p:cNvSpPr txBox="1"/>
+          <p:nvPr/>
+        </p:nvSpPr>
+        <p:spPr>
+          <a:xfrm>
+            <a:off x="685800" y="2505456"/>
+            <a:ext cx="384048" cy="384048"/>
+          </a:xfrm>
+          <a:prstGeom prst="rect">
+            <a:avLst/>
+          </a:prstGeom>
+          <a:noFill/>
+          <a:ln/>
+        </p:spPr>
+        <p:txBody>
+          <a:bodyPr wrap="square" lIns="0" tIns="0" rIns="0" bIns="0" rtlCol="0" anchor="ctr"/>
+          <a:lstStyle/>
+          <a:p>
+            <a:pPr algn="ctr" indent="0" marL="0">
+              <a:buNone/>
+            </a:pPr>
+            <a:r>
+              <a:rPr lang="en-US" sz="1500" b="1" dirty="0">
+                <a:solidFill>
+                  <a:schemeClr val="bg1"/>
+                </a:solidFill>
+              </a:rPr>
+              <a:t>2</a:t>
+            </a:r>
+            <a:endParaRPr lang="en-US" sz="1500" dirty="0"/>
+          </a:p>
+        </p:txBody>
+      </p:sp>
+      <p:sp>
+        <p:nvSpPr>
+          <p:cNvPr id="15" name="Text 13"/>
+          <p:cNvSpPr txBox="1"/>
+          <p:nvPr/>
+        </p:nvSpPr>
+        <p:spPr>
+          <a:xfrm>
+            <a:off x="1188720" y="2359152"/>
+            <a:ext cx="3108960" cy="676656"/>
+          </a:xfrm>
+          <a:prstGeom prst="rect">
+            <a:avLst/>
+          </a:prstGeom>
+          <a:noFill/>
+          <a:ln/>
+        </p:spPr>
+        <p:txBody>
+          <a:bodyPr wrap="square" lIns="0" tIns="0" rIns="0" bIns="0" rtlCol="0" anchor="ctr"/>
+          <a:lstStyle/>
+          <a:p>
+            <a:pPr indent="0" marL="0">
+              <a:buNone/>
+            </a:pPr>
+            <a:r>
+              <a:rPr lang="en-US" sz="1300" b="1" dirty="0">
+                <a:solidFill>
+                  <a:schemeClr val="tx1"/>
+                </a:solidFill>
+              </a:rPr>
+              <a:t>The dataset is mostly daytime and outdoor</a:t>
+            </a:r>
+            <a:endParaRPr lang="en-US" sz="1300" dirty="0"/>
+          </a:p>
+        </p:txBody>
+      </p:sp>
+      <p:sp>
+        <p:nvSpPr>
+          <p:cNvPr id="16" name="Shape 14"/>
+          <p:cNvSpPr/>
+          <p:nvPr/>
+        </p:nvSpPr>
+        <p:spPr>
+          <a:xfrm>
+            <a:off x="4443984" y="2697480"/>
+            <a:ext cx="393192" cy="0"/>
+          </a:xfrm>
+          <a:prstGeom prst="line">
+            <a:avLst/>
+          </a:prstGeom>
+          <a:noFill/>
+          <a:ln w="19050">
+            <a:solidFill>
+              <a:srgbClr val="5B6670"/>
+            </a:solidFill>
+            <a:prstDash val="solid"/>
+            <a:tailEnd type="triangle"/>
+          </a:ln>
+        </p:spPr>
+      </p:sp>
+      <p:sp>
+        <p:nvSpPr>
+          <p:cNvPr id="17" name="Shape 15"/>
+          <p:cNvSpPr/>
+          <p:nvPr/>
+        </p:nvSpPr>
+        <p:spPr>
+          <a:xfrm>
+            <a:off x="4892040" y="2359152"/>
+            <a:ext cx="6720840" cy="676656"/>
+          </a:xfrm>
+          <a:prstGeom prst="roundRect">
+            <a:avLst>
+              <a:gd name="adj" fmla="val 10811"/>
+            </a:avLst>
+          </a:prstGeom>
+          <a:solidFill>
+            <a:schemeClr val="bg2"/>
+          </a:solidFill>
+          <a:ln w="9525">
+            <a:solidFill>
+              <a:srgbClr val="D5DAE0"/>
+            </a:solidFill>
+            <a:prstDash val="solid"/>
+          </a:ln>
+        </p:spPr>
+      </p:sp>
+      <p:sp>
+        <p:nvSpPr>
+          <p:cNvPr id="18" name="Text 16"/>
+          <p:cNvSpPr txBox="1"/>
+          <p:nvPr/>
+        </p:nvSpPr>
+        <p:spPr>
+          <a:xfrm>
+            <a:off x="5074920" y="2359152"/>
+            <a:ext cx="6355080" cy="676656"/>
+          </a:xfrm>
+          <a:prstGeom prst="rect">
+            <a:avLst/>
+          </a:prstGeom>
+          <a:noFill/>
+          <a:ln/>
+        </p:spPr>
+        <p:txBody>
+          <a:bodyPr wrap="square" lIns="0" tIns="0" rIns="0" bIns="0" rtlCol="0" anchor="ctr"/>
+          <a:lstStyle/>
+          <a:p>
+            <a:pPr indent="0" marL="0">
+              <a:buNone/>
+            </a:pPr>
+            <a:r>
+              <a:rPr lang="en-US" sz="1300" dirty="0">
+                <a:solidFill>
+                  <a:schemeClr val="tx1"/>
+                </a:solidFill>
+              </a:rPr>
+              <a:t>Augmentation that imitates the site: low light with sensor noise, infrared-style grey images and motion blur</a:t>
+            </a:r>
+            <a:endParaRPr lang="en-US" sz="1300" dirty="0"/>
+          </a:p>
+        </p:txBody>
+      </p:sp>
+      <p:sp>
+        <p:nvSpPr>
+          <p:cNvPr id="19" name="Shape 17"/>
+          <p:cNvSpPr/>
+          <p:nvPr/>
+        </p:nvSpPr>
+        <p:spPr>
+          <a:xfrm>
+            <a:off x="548640" y="3145536"/>
+            <a:ext cx="3840480" cy="676656"/>
+          </a:xfrm>
+          <a:prstGeom prst="roundRect">
+            <a:avLst>
+              <a:gd name="adj" fmla="val 10811"/>
+            </a:avLst>
+          </a:prstGeom>
+          <a:solidFill>
+            <a:schemeClr val="bg2"/>
+          </a:solidFill>
+          <a:ln w="9525">
+            <a:solidFill>
+              <a:srgbClr val="D5DAE0"/>
+            </a:solidFill>
+            <a:prstDash val="solid"/>
+          </a:ln>
+        </p:spPr>
+      </p:sp>
+      <p:sp>
+        <p:nvSpPr>
+          <p:cNvPr id="20" name="Shape 18"/>
+          <p:cNvSpPr/>
+          <p:nvPr/>
+        </p:nvSpPr>
+        <p:spPr>
+          <a:xfrm>
+            <a:off x="685800" y="3291840"/>
+            <a:ext cx="384048" cy="384048"/>
+          </a:xfrm>
+          <a:prstGeom prst="ellipse">
+            <a:avLst/>
+          </a:prstGeom>
+          <a:solidFill>
+            <a:schemeClr val="accent4"/>
+          </a:solidFill>
+          <a:ln w="12700">
+            <a:solidFill>
+              <a:schemeClr val="accent4"/>
+            </a:solidFill>
+            <a:prstDash val="solid"/>
+          </a:ln>
+        </p:spPr>
+      </p:sp>
+      <p:sp>
+        <p:nvSpPr>
+          <p:cNvPr id="21" name="Text 19"/>
+          <p:cNvSpPr txBox="1"/>
+          <p:nvPr/>
+        </p:nvSpPr>
+        <p:spPr>
+          <a:xfrm>
+            <a:off x="685800" y="3291840"/>
+            <a:ext cx="384048" cy="384048"/>
+          </a:xfrm>
+          <a:prstGeom prst="rect">
+            <a:avLst/>
+          </a:prstGeom>
+          <a:noFill/>
+          <a:ln/>
+        </p:spPr>
+        <p:txBody>
+          <a:bodyPr wrap="square" lIns="0" tIns="0" rIns="0" bIns="0" rtlCol="0" anchor="ctr"/>
+          <a:lstStyle/>
+          <a:p>
+            <a:pPr algn="ctr" indent="0" marL="0">
+              <a:buNone/>
+            </a:pPr>
+            <a:r>
+              <a:rPr lang="en-US" sz="1500" b="1" dirty="0">
+                <a:solidFill>
+                  <a:schemeClr val="bg1"/>
+                </a:solidFill>
+              </a:rPr>
+              <a:t>3</a:t>
+            </a:r>
+            <a:endParaRPr lang="en-US" sz="1500" dirty="0"/>
+          </a:p>
+        </p:txBody>
+      </p:sp>
+      <p:sp>
+        <p:nvSpPr>
+          <p:cNvPr id="22" name="Text 20"/>
+          <p:cNvSpPr txBox="1"/>
+          <p:nvPr/>
+        </p:nvSpPr>
+        <p:spPr>
+          <a:xfrm>
+            <a:off x="1188720" y="3145536"/>
+            <a:ext cx="3108960" cy="676656"/>
+          </a:xfrm>
+          <a:prstGeom prst="rect">
+            <a:avLst/>
+          </a:prstGeom>
+          <a:noFill/>
+          <a:ln/>
+        </p:spPr>
+        <p:txBody>
+          <a:bodyPr wrap="square" lIns="0" tIns="0" rIns="0" bIns="0" rtlCol="0" anchor="ctr"/>
+          <a:lstStyle/>
+          <a:p>
+            <a:pPr indent="0" marL="0">
+              <a:buNone/>
+            </a:pPr>
+            <a:r>
+              <a:rPr lang="en-US" sz="1300" b="1" dirty="0">
+                <a:solidFill>
+                  <a:schemeClr val="tx1"/>
+                </a:solidFill>
+              </a:rPr>
+              <a:t>No examples of fire hidden behind objects</a:t>
+            </a:r>
+            <a:endParaRPr lang="en-US" sz="1300" dirty="0"/>
+          </a:p>
+        </p:txBody>
+      </p:sp>
+      <p:sp>
+        <p:nvSpPr>
+          <p:cNvPr id="23" name="Shape 21"/>
+          <p:cNvSpPr/>
+          <p:nvPr/>
+        </p:nvSpPr>
+        <p:spPr>
+          <a:xfrm>
+            <a:off x="4443984" y="3483864"/>
+            <a:ext cx="393192" cy="0"/>
+          </a:xfrm>
+          <a:prstGeom prst="line">
+            <a:avLst/>
+          </a:prstGeom>
+          <a:noFill/>
+          <a:ln w="19050">
+            <a:solidFill>
+              <a:srgbClr val="5B6670"/>
+            </a:solidFill>
+            <a:prstDash val="solid"/>
+            <a:tailEnd type="triangle"/>
+          </a:ln>
+        </p:spPr>
+      </p:sp>
+      <p:sp>
+        <p:nvSpPr>
+          <p:cNvPr id="24" name="Shape 22"/>
+          <p:cNvSpPr/>
+          <p:nvPr/>
+        </p:nvSpPr>
+        <p:spPr>
+          <a:xfrm>
+            <a:off x="4892040" y="3145536"/>
+            <a:ext cx="6720840" cy="676656"/>
+          </a:xfrm>
+          <a:prstGeom prst="roundRect">
+            <a:avLst>
+              <a:gd name="adj" fmla="val 10811"/>
+            </a:avLst>
+          </a:prstGeom>
+          <a:solidFill>
+            <a:schemeClr val="bg2"/>
+          </a:solidFill>
+          <a:ln w="9525">
+            <a:solidFill>
+              <a:srgbClr val="D5DAE0"/>
+            </a:solidFill>
+            <a:prstDash val="solid"/>
+          </a:ln>
+        </p:spPr>
+      </p:sp>
+      <p:sp>
+        <p:nvSpPr>
+          <p:cNvPr id="25" name="Text 23"/>
+          <p:cNvSpPr txBox="1"/>
+          <p:nvPr/>
+        </p:nvSpPr>
+        <p:spPr>
+          <a:xfrm>
+            <a:off x="5074920" y="3145536"/>
+            <a:ext cx="6355080" cy="676656"/>
+          </a:xfrm>
+          <a:prstGeom prst="rect">
+            <a:avLst/>
+          </a:prstGeom>
+          <a:noFill/>
+          <a:ln/>
+        </p:spPr>
+        <p:txBody>
+          <a:bodyPr wrap="square" lIns="0" tIns="0" rIns="0" bIns="0" rtlCol="0" anchor="ctr"/>
+          <a:lstStyle/>
+          <a:p>
+            <a:pPr indent="0" marL="0">
+              <a:buNone/>
+            </a:pPr>
+            <a:r>
+              <a:rPr lang="en-US" sz="1300" dirty="0">
+                <a:solidFill>
+                  <a:schemeClr val="tx1"/>
+                </a:solidFill>
+              </a:rPr>
+              <a:t>Flames are partly covered during training while the label is kept, and a scene classifier reads 7 glow statistics</a:t>
+            </a:r>
+            <a:endParaRPr lang="en-US" sz="1300" dirty="0"/>
+          </a:p>
+        </p:txBody>
+      </p:sp>
+      <p:sp>
+        <p:nvSpPr>
+          <p:cNvPr id="26" name="Shape 24"/>
+          <p:cNvSpPr/>
+          <p:nvPr/>
+        </p:nvSpPr>
+        <p:spPr>
+          <a:xfrm>
+            <a:off x="548640" y="3931920"/>
+            <a:ext cx="3840480" cy="676656"/>
+          </a:xfrm>
+          <a:prstGeom prst="roundRect">
+            <a:avLst>
+              <a:gd name="adj" fmla="val 10811"/>
+            </a:avLst>
+          </a:prstGeom>
+          <a:solidFill>
+            <a:schemeClr val="bg2"/>
+          </a:solidFill>
+          <a:ln w="9525">
+            <a:solidFill>
+              <a:srgbClr val="D5DAE0"/>
+            </a:solidFill>
+            <a:prstDash val="solid"/>
+          </a:ln>
+        </p:spPr>
+      </p:sp>
+      <p:sp>
+        <p:nvSpPr>
+          <p:cNvPr id="27" name="Shape 25"/>
+          <p:cNvSpPr/>
+          <p:nvPr/>
+        </p:nvSpPr>
+        <p:spPr>
+          <a:xfrm>
+            <a:off x="685800" y="4078224"/>
+            <a:ext cx="384048" cy="384048"/>
+          </a:xfrm>
+          <a:prstGeom prst="ellipse">
+            <a:avLst/>
+          </a:prstGeom>
+          <a:solidFill>
+            <a:schemeClr val="accent4"/>
+          </a:solidFill>
+          <a:ln w="12700">
+            <a:solidFill>
+              <a:schemeClr val="accent4"/>
+            </a:solidFill>
+            <a:prstDash val="solid"/>
+          </a:ln>
+        </p:spPr>
+      </p:sp>
+      <p:sp>
+        <p:nvSpPr>
+          <p:cNvPr id="28" name="Text 26"/>
+          <p:cNvSpPr txBox="1"/>
+          <p:nvPr/>
+        </p:nvSpPr>
+        <p:spPr>
+          <a:xfrm>
+            <a:off x="685800" y="4078224"/>
+            <a:ext cx="384048" cy="384048"/>
+          </a:xfrm>
+          <a:prstGeom prst="rect">
+            <a:avLst/>
+          </a:prstGeom>
+          <a:noFill/>
+          <a:ln/>
+        </p:spPr>
+        <p:txBody>
+          <a:bodyPr wrap="square" lIns="0" tIns="0" rIns="0" bIns="0" rtlCol="0" anchor="ctr"/>
+          <a:lstStyle/>
+          <a:p>
+            <a:pPr algn="ctr" indent="0" marL="0">
+              <a:buNone/>
+            </a:pPr>
+            <a:r>
+              <a:rPr lang="en-US" sz="1500" b="1" dirty="0">
+                <a:solidFill>
+                  <a:schemeClr val="bg1"/>
+                </a:solidFill>
+              </a:rPr>
+              <a:t>4</a:t>
+            </a:r>
+            <a:endParaRPr lang="en-US" sz="1500" dirty="0"/>
+          </a:p>
+        </p:txBody>
+      </p:sp>
+      <p:sp>
+        <p:nvSpPr>
+          <p:cNvPr id="29" name="Text 27"/>
+          <p:cNvSpPr txBox="1"/>
+          <p:nvPr/>
+        </p:nvSpPr>
+        <p:spPr>
+          <a:xfrm>
+            <a:off x="1188720" y="3931920"/>
+            <a:ext cx="3108960" cy="676656"/>
+          </a:xfrm>
+          <a:prstGeom prst="rect">
+            <a:avLst/>
+          </a:prstGeom>
+          <a:noFill/>
+          <a:ln/>
+        </p:spPr>
+        <p:txBody>
+          <a:bodyPr wrap="square" lIns="0" tIns="0" rIns="0" bIns="0" rtlCol="0" anchor="ctr"/>
+          <a:lstStyle/>
+          <a:p>
+            <a:pPr indent="0" marL="0">
+              <a:buNone/>
+            </a:pPr>
+            <a:r>
+              <a:rPr lang="en-US" sz="1300" b="1" dirty="0">
+                <a:solidFill>
+                  <a:schemeClr val="tx1"/>
+                </a:solidFill>
+              </a:rPr>
+              <a:t>False alarms had to be measured, not guessed</a:t>
+            </a:r>
+            <a:endParaRPr lang="en-US" sz="1300" dirty="0"/>
+          </a:p>
+        </p:txBody>
+      </p:sp>
+      <p:sp>
+        <p:nvSpPr>
+          <p:cNvPr id="30" name="Shape 28"/>
+          <p:cNvSpPr/>
+          <p:nvPr/>
+        </p:nvSpPr>
+        <p:spPr>
+          <a:xfrm>
+            <a:off x="4443984" y="4270248"/>
+            <a:ext cx="393192" cy="0"/>
+          </a:xfrm>
+          <a:prstGeom prst="line">
+            <a:avLst/>
+          </a:prstGeom>
+          <a:noFill/>
+          <a:ln w="19050">
+            <a:solidFill>
+              <a:srgbClr val="5B6670"/>
+            </a:solidFill>
+            <a:prstDash val="solid"/>
+            <a:tailEnd type="triangle"/>
+          </a:ln>
+        </p:spPr>
+      </p:sp>
+      <p:sp>
+        <p:nvSpPr>
+          <p:cNvPr id="31" name="Shape 29"/>
+          <p:cNvSpPr/>
+          <p:nvPr/>
+        </p:nvSpPr>
+        <p:spPr>
+          <a:xfrm>
+            <a:off x="4892040" y="3931920"/>
+            <a:ext cx="6720840" cy="676656"/>
+          </a:xfrm>
+          <a:prstGeom prst="roundRect">
+            <a:avLst>
+              <a:gd name="adj" fmla="val 10811"/>
+            </a:avLst>
+          </a:prstGeom>
+          <a:solidFill>
+            <a:schemeClr val="bg2"/>
+          </a:solidFill>
+          <a:ln w="9525">
+            <a:solidFill>
+              <a:srgbClr val="D5DAE0"/>
+            </a:solidFill>
+            <a:prstDash val="solid"/>
+          </a:ln>
+        </p:spPr>
+      </p:sp>
+      <p:sp>
+        <p:nvSpPr>
+          <p:cNvPr id="32" name="Text 30"/>
+          <p:cNvSpPr txBox="1"/>
+          <p:nvPr/>
+        </p:nvSpPr>
+        <p:spPr>
+          <a:xfrm>
+            <a:off x="5074920" y="3931920"/>
+            <a:ext cx="6355080" cy="676656"/>
+          </a:xfrm>
+          <a:prstGeom prst="rect">
+            <a:avLst/>
+          </a:prstGeom>
+          <a:noFill/>
+          <a:ln/>
+        </p:spPr>
+        <p:txBody>
+          <a:bodyPr wrap="square" lIns="0" tIns="0" rIns="0" bIns="0" rtlCol="0" anchor="ctr"/>
+          <a:lstStyle/>
+          <a:p>
+            <a:pPr indent="0" marL="0">
+              <a:buNone/>
+            </a:pPr>
+            <a:r>
+              <a:rPr lang="en-US" sz="1300" dirty="0">
+                <a:solidFill>
+                  <a:schemeClr val="tx1"/>
+                </a:solidFill>
+              </a:rPr>
+              <a:t>45% of the images contain no fire or smoke; the threshold is set where at most 1% of them trigger a detection</a:t>
+            </a:r>
+            <a:endParaRPr lang="en-US" sz="1300" dirty="0"/>
+          </a:p>
+        </p:txBody>
+      </p:sp>
+      <p:sp>
+        <p:nvSpPr>
+          <p:cNvPr id="33" name="Shape 31"/>
+          <p:cNvSpPr/>
+          <p:nvPr/>
+        </p:nvSpPr>
+        <p:spPr>
+          <a:xfrm>
+            <a:off x="548640" y="4718304"/>
+            <a:ext cx="3840480" cy="676656"/>
+          </a:xfrm>
+          <a:prstGeom prst="roundRect">
+            <a:avLst>
+              <a:gd name="adj" fmla="val 10811"/>
+            </a:avLst>
+          </a:prstGeom>
+          <a:solidFill>
+            <a:schemeClr val="bg2"/>
+          </a:solidFill>
+          <a:ln w="9525">
+            <a:solidFill>
+              <a:srgbClr val="D5DAE0"/>
+            </a:solidFill>
+            <a:prstDash val="solid"/>
+          </a:ln>
+        </p:spPr>
+      </p:sp>
+      <p:sp>
+        <p:nvSpPr>
+          <p:cNvPr id="34" name="Shape 32"/>
+          <p:cNvSpPr/>
+          <p:nvPr/>
+        </p:nvSpPr>
+        <p:spPr>
+          <a:xfrm>
+            <a:off x="685800" y="4864608"/>
+            <a:ext cx="384048" cy="384048"/>
+          </a:xfrm>
+          <a:prstGeom prst="ellipse">
+            <a:avLst/>
+          </a:prstGeom>
+          <a:solidFill>
+            <a:schemeClr val="accent4"/>
+          </a:solidFill>
+          <a:ln w="12700">
+            <a:solidFill>
+              <a:schemeClr val="accent4"/>
+            </a:solidFill>
+            <a:prstDash val="solid"/>
+          </a:ln>
+        </p:spPr>
+      </p:sp>
+      <p:sp>
+        <p:nvSpPr>
+          <p:cNvPr id="35" name="Text 33"/>
+          <p:cNvSpPr txBox="1"/>
+          <p:nvPr/>
+        </p:nvSpPr>
+        <p:spPr>
+          <a:xfrm>
+            <a:off x="685800" y="4864608"/>
+            <a:ext cx="384048" cy="384048"/>
+          </a:xfrm>
+          <a:prstGeom prst="rect">
+            <a:avLst/>
+          </a:prstGeom>
+          <a:noFill/>
+          <a:ln/>
+        </p:spPr>
+        <p:txBody>
+          <a:bodyPr wrap="square" lIns="0" tIns="0" rIns="0" bIns="0" rtlCol="0" anchor="ctr"/>
+          <a:lstStyle/>
+          <a:p>
+            <a:pPr algn="ctr" indent="0" marL="0">
+              <a:buNone/>
+            </a:pPr>
+            <a:r>
+              <a:rPr lang="en-US" sz="1500" b="1" dirty="0">
+                <a:solidFill>
+                  <a:schemeClr val="bg1"/>
+                </a:solidFill>
+              </a:rPr>
+              <a:t>5</a:t>
+            </a:r>
+            <a:endParaRPr lang="en-US" sz="1500" dirty="0"/>
+          </a:p>
+        </p:txBody>
+      </p:sp>
+      <p:sp>
+        <p:nvSpPr>
+          <p:cNvPr id="36" name="Text 34"/>
+          <p:cNvSpPr txBox="1"/>
+          <p:nvPr/>
+        </p:nvSpPr>
+        <p:spPr>
+          <a:xfrm>
+            <a:off x="1188720" y="4718304"/>
+            <a:ext cx="3108960" cy="676656"/>
+          </a:xfrm>
+          <a:prstGeom prst="rect">
+            <a:avLst/>
+          </a:prstGeom>
+          <a:noFill/>
+          <a:ln/>
+        </p:spPr>
+        <p:txBody>
+          <a:bodyPr wrap="square" lIns="0" tIns="0" rIns="0" bIns="0" rtlCol="0" anchor="ctr"/>
+          <a:lstStyle/>
+          <a:p>
+            <a:pPr indent="0" marL="0">
+              <a:buNone/>
+            </a:pPr>
+            <a:r>
+              <a:rPr lang="en-US" sz="1300" b="1" dirty="0">
+                <a:solidFill>
+                  <a:schemeClr val="tx1"/>
+                </a:solidFill>
+              </a:rPr>
+              <a:t>Limited GPU time: free Kaggle sessions with a time limit</a:t>
+            </a:r>
+            <a:endParaRPr lang="en-US" sz="1300" dirty="0"/>
+          </a:p>
+        </p:txBody>
+      </p:sp>
+      <p:sp>
+        <p:nvSpPr>
+          <p:cNvPr id="37" name="Shape 35"/>
+          <p:cNvSpPr/>
+          <p:nvPr/>
+        </p:nvSpPr>
+        <p:spPr>
+          <a:xfrm>
+            <a:off x="4443984" y="5056632"/>
+            <a:ext cx="393192" cy="0"/>
+          </a:xfrm>
+          <a:prstGeom prst="line">
+            <a:avLst/>
+          </a:prstGeom>
+          <a:noFill/>
+          <a:ln w="19050">
+            <a:solidFill>
+              <a:srgbClr val="5B6670"/>
+            </a:solidFill>
+            <a:prstDash val="solid"/>
+            <a:tailEnd type="triangle"/>
+          </a:ln>
+        </p:spPr>
+      </p:sp>
+      <p:sp>
+        <p:nvSpPr>
+          <p:cNvPr id="38" name="Shape 36"/>
+          <p:cNvSpPr/>
+          <p:nvPr/>
+        </p:nvSpPr>
+        <p:spPr>
+          <a:xfrm>
+            <a:off x="4892040" y="4718304"/>
+            <a:ext cx="6720840" cy="676656"/>
+          </a:xfrm>
+          <a:prstGeom prst="roundRect">
+            <a:avLst>
+              <a:gd name="adj" fmla="val 10811"/>
+            </a:avLst>
+          </a:prstGeom>
+          <a:solidFill>
+            <a:schemeClr val="bg2"/>
+          </a:solidFill>
+          <a:ln w="9525">
+            <a:solidFill>
+              <a:srgbClr val="D5DAE0"/>
+            </a:solidFill>
+            <a:prstDash val="solid"/>
+          </a:ln>
+        </p:spPr>
+      </p:sp>
+      <p:sp>
+        <p:nvSpPr>
+          <p:cNvPr id="39" name="Text 37"/>
+          <p:cNvSpPr txBox="1"/>
+          <p:nvPr/>
+        </p:nvSpPr>
+        <p:spPr>
+          <a:xfrm>
+            <a:off x="5074920" y="4718304"/>
+            <a:ext cx="6355080" cy="676656"/>
+          </a:xfrm>
+          <a:prstGeom prst="rect">
+            <a:avLst/>
+          </a:prstGeom>
+          <a:noFill/>
+          <a:ln/>
+        </p:spPr>
+        <p:txBody>
+          <a:bodyPr wrap="square" lIns="0" tIns="0" rIns="0" bIns="0" rtlCol="0" anchor="ctr"/>
+          <a:lstStyle/>
+          <a:p>
+            <a:pPr indent="0" marL="0">
+              <a:buNone/>
+            </a:pPr>
+            <a:r>
+              <a:rPr lang="en-US" sz="1300" dirty="0">
+                <a:solidFill>
+                  <a:schemeClr val="tx1"/>
+                </a:solidFill>
+              </a:rPr>
+              <a:t>The backbone is frozen, which makes training cheap; a checkpoint is saved after every epoch so a run can resume</a:t>
+            </a:r>
+            <a:endParaRPr lang="en-US" sz="1300" dirty="0"/>
+          </a:p>
+        </p:txBody>
+      </p:sp>
+      <p:sp>
+        <p:nvSpPr>
+          <p:cNvPr id="40" name="Shape 38"/>
+          <p:cNvSpPr/>
+          <p:nvPr/>
+        </p:nvSpPr>
+        <p:spPr>
+          <a:xfrm>
+            <a:off x="548640" y="5504688"/>
+            <a:ext cx="3840480" cy="676656"/>
+          </a:xfrm>
+          <a:prstGeom prst="roundRect">
+            <a:avLst>
+              <a:gd name="adj" fmla="val 10811"/>
+            </a:avLst>
+          </a:prstGeom>
+          <a:solidFill>
+            <a:schemeClr val="bg2"/>
+          </a:solidFill>
+          <a:ln w="9525">
+            <a:solidFill>
+              <a:srgbClr val="D5DAE0"/>
+            </a:solidFill>
+            <a:prstDash val="solid"/>
+          </a:ln>
+        </p:spPr>
+      </p:sp>
+      <p:sp>
+        <p:nvSpPr>
+          <p:cNvPr id="41" name="Shape 39"/>
+          <p:cNvSpPr/>
+          <p:nvPr/>
+        </p:nvSpPr>
+        <p:spPr>
+          <a:xfrm>
+            <a:off x="685800" y="5650992"/>
+            <a:ext cx="384048" cy="384048"/>
+          </a:xfrm>
+          <a:prstGeom prst="ellipse">
+            <a:avLst/>
+          </a:prstGeom>
+          <a:solidFill>
+            <a:schemeClr val="accent4"/>
+          </a:solidFill>
+          <a:ln w="12700">
+            <a:solidFill>
+              <a:schemeClr val="accent4"/>
+            </a:solidFill>
+            <a:prstDash val="solid"/>
+          </a:ln>
+        </p:spPr>
+      </p:sp>
+      <p:sp>
+        <p:nvSpPr>
+          <p:cNvPr id="42" name="Text 40"/>
+          <p:cNvSpPr txBox="1"/>
+          <p:nvPr/>
+        </p:nvSpPr>
+        <p:spPr>
+          <a:xfrm>
+            <a:off x="685800" y="5650992"/>
+            <a:ext cx="384048" cy="384048"/>
+          </a:xfrm>
+          <a:prstGeom prst="rect">
+            <a:avLst/>
+          </a:prstGeom>
+          <a:noFill/>
+          <a:ln/>
+        </p:spPr>
+        <p:txBody>
+          <a:bodyPr wrap="square" lIns="0" tIns="0" rIns="0" bIns="0" rtlCol="0" anchor="ctr"/>
+          <a:lstStyle/>
+          <a:p>
+            <a:pPr algn="ctr" indent="0" marL="0">
+              <a:buNone/>
+            </a:pPr>
+            <a:r>
+              <a:rPr lang="en-US" sz="1500" b="1" dirty="0">
+                <a:solidFill>
+                  <a:schemeClr val="bg1"/>
+                </a:solidFill>
+              </a:rPr>
+              <a:t>6</a:t>
+            </a:r>
+            <a:endParaRPr lang="en-US" sz="1500" dirty="0"/>
+          </a:p>
+        </p:txBody>
+      </p:sp>
+      <p:sp>
+        <p:nvSpPr>
+          <p:cNvPr id="43" name="Text 41"/>
+          <p:cNvSpPr txBox="1"/>
+          <p:nvPr/>
+        </p:nvSpPr>
+        <p:spPr>
+          <a:xfrm>
+            <a:off x="1188720" y="5504688"/>
+            <a:ext cx="3108960" cy="676656"/>
+          </a:xfrm>
+          <a:prstGeom prst="rect">
+            <a:avLst/>
+          </a:prstGeom>
+          <a:noFill/>
+          <a:ln/>
+        </p:spPr>
+        <p:txBody>
+          <a:bodyPr wrap="square" lIns="0" tIns="0" rIns="0" bIns="0" rtlCol="0" anchor="ctr"/>
+          <a:lstStyle/>
+          <a:p>
+            <a:pPr indent="0" marL="0">
+              <a:buNone/>
+            </a:pPr>
+            <a:r>
+              <a:rPr lang="en-US" sz="1300" b="1" dirty="0">
+                <a:solidFill>
+                  <a:schemeClr val="tx1"/>
+                </a:solidFill>
+              </a:rPr>
+              <a:t>DINOv3 gives features at one scale only</a:t>
+            </a:r>
+            <a:endParaRPr lang="en-US" sz="1300" dirty="0"/>
+          </a:p>
+        </p:txBody>
+      </p:sp>
+      <p:sp>
+        <p:nvSpPr>
+          <p:cNvPr id="44" name="Shape 42"/>
+          <p:cNvSpPr/>
+          <p:nvPr/>
+        </p:nvSpPr>
+        <p:spPr>
+          <a:xfrm>
+            <a:off x="4443984" y="5843016"/>
+            <a:ext cx="393192" cy="0"/>
+          </a:xfrm>
+          <a:prstGeom prst="line">
+            <a:avLst/>
+          </a:prstGeom>
+          <a:noFill/>
+          <a:ln w="19050">
+            <a:solidFill>
+              <a:srgbClr val="5B6670"/>
+            </a:solidFill>
+            <a:prstDash val="solid"/>
+            <a:tailEnd type="triangle"/>
+          </a:ln>
+        </p:spPr>
+      </p:sp>
+      <p:sp>
+        <p:nvSpPr>
+          <p:cNvPr id="45" name="Shape 43"/>
+          <p:cNvSpPr/>
+          <p:nvPr/>
+        </p:nvSpPr>
+        <p:spPr>
+          <a:xfrm>
+            <a:off x="4892040" y="5504688"/>
+            <a:ext cx="6720840" cy="676656"/>
+          </a:xfrm>
+          <a:prstGeom prst="roundRect">
+            <a:avLst>
+              <a:gd name="adj" fmla="val 10811"/>
+            </a:avLst>
+          </a:prstGeom>
+          <a:solidFill>
+            <a:schemeClr val="bg2"/>
+          </a:solidFill>
+          <a:ln w="9525">
+            <a:solidFill>
+              <a:srgbClr val="D5DAE0"/>
+            </a:solidFill>
+            <a:prstDash val="solid"/>
+          </a:ln>
+        </p:spPr>
+      </p:sp>
+      <p:sp>
+        <p:nvSpPr>
+          <p:cNvPr id="46" name="Text 44"/>
+          <p:cNvSpPr txBox="1"/>
+          <p:nvPr/>
+        </p:nvSpPr>
+        <p:spPr>
+          <a:xfrm>
+            <a:off x="5074920" y="5504688"/>
+            <a:ext cx="6355080" cy="676656"/>
+          </a:xfrm>
+          <a:prstGeom prst="rect">
+            <a:avLst/>
+          </a:prstGeom>
+          <a:noFill/>
+          <a:ln/>
+        </p:spPr>
+        <p:txBody>
+          <a:bodyPr wrap="square" lIns="0" tIns="0" rIns="0" bIns="0" rtlCol="0" anchor="ctr"/>
+          <a:lstStyle/>
+          <a:p>
+            <a:pPr indent="0" marL="0">
+              <a:buNone/>
+            </a:pPr>
+            <a:r>
+              <a:rPr lang="en-US" sz="1300" dirty="0">
+                <a:solidFill>
+                  <a:schemeClr val="tx1"/>
+                </a:solidFill>
+              </a:rPr>
+              <a:t>A 4-level feature pyramid was built on top of it, so small and large fires are both covered</a:t>
+            </a:r>
+            <a:endParaRPr lang="en-US" sz="1300" dirty="0"/>
+          </a:p>
+        </p:txBody>
+      </p:sp>
+      <p:sp>
+        <p:nvSpPr>
+          <p:cNvPr id="25" name="Slide Number Placeholder 0"/>
+          <p:cNvSpPr>
+            <a:spLocks noGrp="1"/>
+          </p:cNvSpPr>
+          <p:nvPr>
+            <p:ph type="sldNum" sz="quarter" idx="4294967295"/>
+          </p:nvPr>
+        </p:nvSpPr>
+        <p:spPr>
+          <a:xfrm>
+            <a:off x="11155680" y="6400800"/>
+            <a:ext cx="548640" cy="274320"/>
+          </a:xfrm>
+          <a:prstGeom prst="rect">
+            <a:avLst/>
+          </a:prstGeom>
+          <a:extLst>
+            <a:ext uri="{C572A759-6A51-4108-AA02-DFA0A04FC94B}">
+              <ma14:wrappingTextBoxFlag xmlns:ma14="http://schemas.microsoft.com/office/mac/drawingml/2011/main" val="0"/>
+            </a:ext>
+          </a:extLst>
+        </p:spPr>
+        <p:txBody>
+          <a:bodyPr/>
+          <a:lstStyle>
+            <a:lvl1pPr>
+              <a:defRPr sz="1000">
+                <a:solidFill>
+                  <a:srgbClr val="5B6670"/>
+                </a:solidFill>
+              </a:defRPr>
+            </a:lvl1pPr>
+          </a:lstStyle>
+          <a:p>
+            <a:pPr algn="r"/>
+            <a:fld id="{F7021451-1387-4CA6-816F-3879F97B5CBC}" type="slidenum">
+              <a:rPr b="0" lang="en-US"/>
+              <a:t>13</a:t>
+            </a:fld>
+            <a:endParaRPr lang="en-US"/>
+          </a:p>
+        </p:txBody>
+      </p:sp>
+    </p:spTree>
+  </p:cSld>
+  <p:clrMapOvr>
+    <a:masterClrMapping/>
+  </p:clrMapOvr>
+</p:sld>
+</file>
+
+<file path=ppt/slides/slide14.xml><?xml version="1.0" encoding="utf-8"?>
+<p:sld xmlns:a="http://schemas.openxmlformats.org/drawingml/2006/main" xmlns:r="http://schemas.openxmlformats.org/officeDocument/2006/relationships" xmlns:p="http://schemas.openxmlformats.org/presentationml/2006/main">
+  <p:cSld name="Slide 14">
+    <p:spTree>
+      <p:nvGrpSpPr>
+        <p:cNvPr id="1" name=""/>
+        <p:cNvGrpSpPr/>
+        <p:nvPr/>
+      </p:nvGrpSpPr>
+      <p:grpSpPr>
+        <a:xfrm>
+          <a:off x="0" y="0"/>
+          <a:ext cx="0" cy="0"/>
+          <a:chOff x="0" y="0"/>
+          <a:chExt cx="0" cy="0"/>
+        </a:xfrm>
+      </p:grpSpPr>
+      <p:sp>
+        <p:nvSpPr>
+          <p:cNvPr id="2" name="Text 0"/>
+          <p:cNvSpPr/>
+          <p:nvPr>
+            <p:ph idx="100" type="title" hasCustomPrompt="1"/>
+          </p:nvPr>
+        </p:nvSpPr>
+        <p:spPr>
+          <a:xfrm>
+            <a:off x="548640" y="274320"/>
+            <a:ext cx="11064240" cy="822960"/>
+          </a:xfrm>
+          <a:prstGeom prst="rect">
+            <a:avLst/>
+          </a:prstGeom>
+          <a:noFill/>
+          <a:ln/>
+        </p:spPr>
+        <p:txBody>
+          <a:bodyPr wrap="square" lIns="0" tIns="0" rIns="0" bIns="0" rtlCol="0" anchor="ctr"/>
+          <a:lstStyle/>
+          <a:p>
+            <a:pPr algn="l" indent="0" marL="0">
+              <a:buNone/>
+            </a:pPr>
+            <a:r>
+              <a:rPr lang="en-US" sz="3000" b="1" dirty="0">
+                <a:solidFill>
+                  <a:schemeClr val="tx1"/>
+                </a:solidFill>
+              </a:rPr>
+              <a:t>Next goals</a:t>
+            </a:r>
+            <a:endParaRPr lang="en-US" sz="3000" dirty="0"/>
+          </a:p>
+        </p:txBody>
+      </p:sp>
+      <p:sp>
+        <p:nvSpPr>
+          <p:cNvPr id="3" name="Shape 1"/>
+          <p:cNvSpPr/>
+          <p:nvPr/>
+        </p:nvSpPr>
+        <p:spPr>
+          <a:xfrm>
+            <a:off x="548640" y="1325880"/>
+            <a:ext cx="5440680" cy="1024128"/>
+          </a:xfrm>
+          <a:prstGeom prst="roundRect">
+            <a:avLst>
+              <a:gd name="adj" fmla="val 7143"/>
+            </a:avLst>
+          </a:prstGeom>
+          <a:solidFill>
+            <a:schemeClr val="bg2"/>
+          </a:solidFill>
+          <a:ln w="9525">
+            <a:solidFill>
+              <a:srgbClr val="D5DAE0"/>
+            </a:solidFill>
+            <a:prstDash val="solid"/>
+          </a:ln>
+        </p:spPr>
+      </p:sp>
+      <p:sp>
+        <p:nvSpPr>
           <p:cNvPr id="4" name="Shape 2"/>
           <p:cNvSpPr/>
           <p:nvPr/>
@@ -7847,7 +10861,7 @@
             <a:pPr algn="r"/>
             <a:fld id="{F7021451-1387-4CA6-816F-3879F97B5CBC}" type="slidenum">
               <a:rPr b="0" lang="en-US"/>
-              <a:t>12</a:t>
+              <a:t>14</a:t>
             </a:fld>
             <a:endParaRPr lang="en-US"/>
           </a:p>

</xml_diff>